<commit_message>
Added finished powerpoint and related images to designated folder for meeting 08
</commit_message>
<xml_diff>
--- a/dev_documents/meetings/meeting_08/meeting_08.pptx
+++ b/dev_documents/meetings/meeting_08/meeting_08.pptx
@@ -4,6 +4,9 @@
   <p:sldMasterIdLst>
     <p:sldMasterId id="2147483648" r:id="rId1"/>
   </p:sldMasterIdLst>
+  <p:notesMasterIdLst>
+    <p:notesMasterId r:id="rId24"/>
+  </p:notesMasterIdLst>
   <p:sldIdLst>
     <p:sldId id="256" r:id="rId2"/>
     <p:sldId id="258" r:id="rId3"/>
@@ -12,6 +15,21 @@
     <p:sldId id="277" r:id="rId6"/>
     <p:sldId id="278" r:id="rId7"/>
     <p:sldId id="279" r:id="rId8"/>
+    <p:sldId id="291" r:id="rId9"/>
+    <p:sldId id="293" r:id="rId10"/>
+    <p:sldId id="292" r:id="rId11"/>
+    <p:sldId id="280" r:id="rId12"/>
+    <p:sldId id="281" r:id="rId13"/>
+    <p:sldId id="295" r:id="rId14"/>
+    <p:sldId id="282" r:id="rId15"/>
+    <p:sldId id="283" r:id="rId16"/>
+    <p:sldId id="287" r:id="rId17"/>
+    <p:sldId id="284" r:id="rId18"/>
+    <p:sldId id="285" r:id="rId19"/>
+    <p:sldId id="288" r:id="rId20"/>
+    <p:sldId id="289" r:id="rId21"/>
+    <p:sldId id="290" r:id="rId22"/>
+    <p:sldId id="296" r:id="rId23"/>
   </p:sldIdLst>
   <p:sldSz cx="12192000" cy="6858000"/>
   <p:notesSz cx="6858000" cy="9144000"/>
@@ -110,7 +128,446 @@
       </a:defRPr>
     </a:lvl9pPr>
   </p:defaultTextStyle>
+  <p:extLst>
+    <p:ext uri="{EFAFB233-063F-42B5-8137-9DF3F51BA10A}">
+      <p15:sldGuideLst xmlns:p15="http://schemas.microsoft.com/office/powerpoint/2012/main"/>
+    </p:ext>
+  </p:extLst>
 </p:presentation>
+</file>
+
+<file path=ppt/notesMasters/notesMaster1.xml><?xml version="1.0" encoding="utf-8"?>
+<p:notesMaster xmlns:a="http://schemas.openxmlformats.org/drawingml/2006/main" xmlns:r="http://schemas.openxmlformats.org/officeDocument/2006/relationships" xmlns:p="http://schemas.openxmlformats.org/presentationml/2006/main">
+  <p:cSld>
+    <p:bg>
+      <p:bgRef idx="1001">
+        <a:schemeClr val="bg1"/>
+      </p:bgRef>
+    </p:bg>
+    <p:spTree>
+      <p:nvGrpSpPr>
+        <p:cNvPr id="1" name=""/>
+        <p:cNvGrpSpPr/>
+        <p:nvPr/>
+      </p:nvGrpSpPr>
+      <p:grpSpPr>
+        <a:xfrm>
+          <a:off x="0" y="0"/>
+          <a:ext cx="0" cy="0"/>
+          <a:chOff x="0" y="0"/>
+          <a:chExt cx="0" cy="0"/>
+        </a:xfrm>
+      </p:grpSpPr>
+      <p:sp>
+        <p:nvSpPr>
+          <p:cNvPr id="2" name="Kopfzeilenplatzhalter 1"/>
+          <p:cNvSpPr>
+            <a:spLocks noGrp="1"/>
+          </p:cNvSpPr>
+          <p:nvPr>
+            <p:ph type="hdr" sz="quarter"/>
+          </p:nvPr>
+        </p:nvSpPr>
+        <p:spPr>
+          <a:xfrm>
+            <a:off x="0" y="0"/>
+            <a:ext cx="2971800" cy="458788"/>
+          </a:xfrm>
+          <a:prstGeom prst="rect">
+            <a:avLst/>
+          </a:prstGeom>
+        </p:spPr>
+        <p:txBody>
+          <a:bodyPr vert="horz" lIns="91440" tIns="45720" rIns="91440" bIns="45720" rtlCol="0"/>
+          <a:lstStyle>
+            <a:lvl1pPr algn="l">
+              <a:defRPr sz="1200"/>
+            </a:lvl1pPr>
+          </a:lstStyle>
+          <a:p>
+            <a:endParaRPr lang="de-CH"/>
+          </a:p>
+        </p:txBody>
+      </p:sp>
+      <p:sp>
+        <p:nvSpPr>
+          <p:cNvPr id="3" name="Datumsplatzhalter 2"/>
+          <p:cNvSpPr>
+            <a:spLocks noGrp="1"/>
+          </p:cNvSpPr>
+          <p:nvPr>
+            <p:ph type="dt" idx="1"/>
+          </p:nvPr>
+        </p:nvSpPr>
+        <p:spPr>
+          <a:xfrm>
+            <a:off x="3884613" y="0"/>
+            <a:ext cx="2971800" cy="458788"/>
+          </a:xfrm>
+          <a:prstGeom prst="rect">
+            <a:avLst/>
+          </a:prstGeom>
+        </p:spPr>
+        <p:txBody>
+          <a:bodyPr vert="horz" lIns="91440" tIns="45720" rIns="91440" bIns="45720" rtlCol="0"/>
+          <a:lstStyle>
+            <a:lvl1pPr algn="r">
+              <a:defRPr sz="1200"/>
+            </a:lvl1pPr>
+          </a:lstStyle>
+          <a:p>
+            <a:fld id="{0EEDA85C-7561-4EE7-B3C9-F79BF35623C4}" type="datetimeFigureOut">
+              <a:rPr lang="de-CH" smtClean="0"/>
+              <a:t>09.01.2026</a:t>
+            </a:fld>
+            <a:endParaRPr lang="de-CH"/>
+          </a:p>
+        </p:txBody>
+      </p:sp>
+      <p:sp>
+        <p:nvSpPr>
+          <p:cNvPr id="4" name="Folienbildplatzhalter 3"/>
+          <p:cNvSpPr>
+            <a:spLocks noGrp="1" noRot="1" noChangeAspect="1"/>
+          </p:cNvSpPr>
+          <p:nvPr>
+            <p:ph type="sldImg" idx="2"/>
+          </p:nvPr>
+        </p:nvSpPr>
+        <p:spPr>
+          <a:xfrm>
+            <a:off x="685800" y="1143000"/>
+            <a:ext cx="5486400" cy="3086100"/>
+          </a:xfrm>
+          <a:prstGeom prst="rect">
+            <a:avLst/>
+          </a:prstGeom>
+          <a:noFill/>
+          <a:ln w="12700">
+            <a:solidFill>
+              <a:prstClr val="black"/>
+            </a:solidFill>
+          </a:ln>
+        </p:spPr>
+        <p:txBody>
+          <a:bodyPr vert="horz" lIns="91440" tIns="45720" rIns="91440" bIns="45720" rtlCol="0" anchor="ctr"/>
+          <a:lstStyle/>
+          <a:p>
+            <a:endParaRPr lang="de-CH"/>
+          </a:p>
+        </p:txBody>
+      </p:sp>
+      <p:sp>
+        <p:nvSpPr>
+          <p:cNvPr id="5" name="Notizenplatzhalter 4"/>
+          <p:cNvSpPr>
+            <a:spLocks noGrp="1"/>
+          </p:cNvSpPr>
+          <p:nvPr>
+            <p:ph type="body" sz="quarter" idx="3"/>
+          </p:nvPr>
+        </p:nvSpPr>
+        <p:spPr>
+          <a:xfrm>
+            <a:off x="685800" y="4400550"/>
+            <a:ext cx="5486400" cy="3600450"/>
+          </a:xfrm>
+          <a:prstGeom prst="rect">
+            <a:avLst/>
+          </a:prstGeom>
+        </p:spPr>
+        <p:txBody>
+          <a:bodyPr vert="horz" lIns="91440" tIns="45720" rIns="91440" bIns="45720" rtlCol="0"/>
+          <a:lstStyle/>
+          <a:p>
+            <a:pPr lvl="0"/>
+            <a:r>
+              <a:rPr lang="de-DE"/>
+              <a:t>Mastertextformat bearbeiten</a:t>
+            </a:r>
+          </a:p>
+          <a:p>
+            <a:pPr lvl="1"/>
+            <a:r>
+              <a:rPr lang="de-DE"/>
+              <a:t>Zweite Ebene</a:t>
+            </a:r>
+          </a:p>
+          <a:p>
+            <a:pPr lvl="2"/>
+            <a:r>
+              <a:rPr lang="de-DE"/>
+              <a:t>Dritte Ebene</a:t>
+            </a:r>
+          </a:p>
+          <a:p>
+            <a:pPr lvl="3"/>
+            <a:r>
+              <a:rPr lang="de-DE"/>
+              <a:t>Vierte Ebene</a:t>
+            </a:r>
+          </a:p>
+          <a:p>
+            <a:pPr lvl="4"/>
+            <a:r>
+              <a:rPr lang="de-DE"/>
+              <a:t>Fünfte Ebene</a:t>
+            </a:r>
+            <a:endParaRPr lang="de-CH"/>
+          </a:p>
+        </p:txBody>
+      </p:sp>
+      <p:sp>
+        <p:nvSpPr>
+          <p:cNvPr id="6" name="Fußzeilenplatzhalter 5"/>
+          <p:cNvSpPr>
+            <a:spLocks noGrp="1"/>
+          </p:cNvSpPr>
+          <p:nvPr>
+            <p:ph type="ftr" sz="quarter" idx="4"/>
+          </p:nvPr>
+        </p:nvSpPr>
+        <p:spPr>
+          <a:xfrm>
+            <a:off x="0" y="8685213"/>
+            <a:ext cx="2971800" cy="458787"/>
+          </a:xfrm>
+          <a:prstGeom prst="rect">
+            <a:avLst/>
+          </a:prstGeom>
+        </p:spPr>
+        <p:txBody>
+          <a:bodyPr vert="horz" lIns="91440" tIns="45720" rIns="91440" bIns="45720" rtlCol="0" anchor="b"/>
+          <a:lstStyle>
+            <a:lvl1pPr algn="l">
+              <a:defRPr sz="1200"/>
+            </a:lvl1pPr>
+          </a:lstStyle>
+          <a:p>
+            <a:endParaRPr lang="de-CH"/>
+          </a:p>
+        </p:txBody>
+      </p:sp>
+      <p:sp>
+        <p:nvSpPr>
+          <p:cNvPr id="7" name="Foliennummernplatzhalter 6"/>
+          <p:cNvSpPr>
+            <a:spLocks noGrp="1"/>
+          </p:cNvSpPr>
+          <p:nvPr>
+            <p:ph type="sldNum" sz="quarter" idx="5"/>
+          </p:nvPr>
+        </p:nvSpPr>
+        <p:spPr>
+          <a:xfrm>
+            <a:off x="3884613" y="8685213"/>
+            <a:ext cx="2971800" cy="458787"/>
+          </a:xfrm>
+          <a:prstGeom prst="rect">
+            <a:avLst/>
+          </a:prstGeom>
+        </p:spPr>
+        <p:txBody>
+          <a:bodyPr vert="horz" lIns="91440" tIns="45720" rIns="91440" bIns="45720" rtlCol="0" anchor="b"/>
+          <a:lstStyle>
+            <a:lvl1pPr algn="r">
+              <a:defRPr sz="1200"/>
+            </a:lvl1pPr>
+          </a:lstStyle>
+          <a:p>
+            <a:fld id="{0B4C1694-879D-4CEF-B0E1-3CF57A3A99BD}" type="slidenum">
+              <a:rPr lang="de-CH" smtClean="0"/>
+              <a:t>‹Nr.›</a:t>
+            </a:fld>
+            <a:endParaRPr lang="de-CH"/>
+          </a:p>
+        </p:txBody>
+      </p:sp>
+    </p:spTree>
+    <p:extLst>
+      <p:ext uri="{BB962C8B-B14F-4D97-AF65-F5344CB8AC3E}">
+        <p14:creationId xmlns:p14="http://schemas.microsoft.com/office/powerpoint/2010/main" val="2025759176"/>
+      </p:ext>
+    </p:extLst>
+  </p:cSld>
+  <p:clrMap bg1="lt1" tx1="dk1" bg2="lt2" tx2="dk2" accent1="accent1" accent2="accent2" accent3="accent3" accent4="accent4" accent5="accent5" accent6="accent6" hlink="hlink" folHlink="folHlink"/>
+  <p:notesStyle>
+    <a:lvl1pPr marL="0" algn="l" defTabSz="914400" rtl="0" eaLnBrk="1" latinLnBrk="0" hangingPunct="1">
+      <a:defRPr sz="1200" kern="1200">
+        <a:solidFill>
+          <a:schemeClr val="tx1"/>
+        </a:solidFill>
+        <a:latin typeface="+mn-lt"/>
+        <a:ea typeface="+mn-ea"/>
+        <a:cs typeface="+mn-cs"/>
+      </a:defRPr>
+    </a:lvl1pPr>
+    <a:lvl2pPr marL="457200" algn="l" defTabSz="914400" rtl="0" eaLnBrk="1" latinLnBrk="0" hangingPunct="1">
+      <a:defRPr sz="1200" kern="1200">
+        <a:solidFill>
+          <a:schemeClr val="tx1"/>
+        </a:solidFill>
+        <a:latin typeface="+mn-lt"/>
+        <a:ea typeface="+mn-ea"/>
+        <a:cs typeface="+mn-cs"/>
+      </a:defRPr>
+    </a:lvl2pPr>
+    <a:lvl3pPr marL="914400" algn="l" defTabSz="914400" rtl="0" eaLnBrk="1" latinLnBrk="0" hangingPunct="1">
+      <a:defRPr sz="1200" kern="1200">
+        <a:solidFill>
+          <a:schemeClr val="tx1"/>
+        </a:solidFill>
+        <a:latin typeface="+mn-lt"/>
+        <a:ea typeface="+mn-ea"/>
+        <a:cs typeface="+mn-cs"/>
+      </a:defRPr>
+    </a:lvl3pPr>
+    <a:lvl4pPr marL="1371600" algn="l" defTabSz="914400" rtl="0" eaLnBrk="1" latinLnBrk="0" hangingPunct="1">
+      <a:defRPr sz="1200" kern="1200">
+        <a:solidFill>
+          <a:schemeClr val="tx1"/>
+        </a:solidFill>
+        <a:latin typeface="+mn-lt"/>
+        <a:ea typeface="+mn-ea"/>
+        <a:cs typeface="+mn-cs"/>
+      </a:defRPr>
+    </a:lvl4pPr>
+    <a:lvl5pPr marL="1828800" algn="l" defTabSz="914400" rtl="0" eaLnBrk="1" latinLnBrk="0" hangingPunct="1">
+      <a:defRPr sz="1200" kern="1200">
+        <a:solidFill>
+          <a:schemeClr val="tx1"/>
+        </a:solidFill>
+        <a:latin typeface="+mn-lt"/>
+        <a:ea typeface="+mn-ea"/>
+        <a:cs typeface="+mn-cs"/>
+      </a:defRPr>
+    </a:lvl5pPr>
+    <a:lvl6pPr marL="2286000" algn="l" defTabSz="914400" rtl="0" eaLnBrk="1" latinLnBrk="0" hangingPunct="1">
+      <a:defRPr sz="1200" kern="1200">
+        <a:solidFill>
+          <a:schemeClr val="tx1"/>
+        </a:solidFill>
+        <a:latin typeface="+mn-lt"/>
+        <a:ea typeface="+mn-ea"/>
+        <a:cs typeface="+mn-cs"/>
+      </a:defRPr>
+    </a:lvl6pPr>
+    <a:lvl7pPr marL="2743200" algn="l" defTabSz="914400" rtl="0" eaLnBrk="1" latinLnBrk="0" hangingPunct="1">
+      <a:defRPr sz="1200" kern="1200">
+        <a:solidFill>
+          <a:schemeClr val="tx1"/>
+        </a:solidFill>
+        <a:latin typeface="+mn-lt"/>
+        <a:ea typeface="+mn-ea"/>
+        <a:cs typeface="+mn-cs"/>
+      </a:defRPr>
+    </a:lvl7pPr>
+    <a:lvl8pPr marL="3200400" algn="l" defTabSz="914400" rtl="0" eaLnBrk="1" latinLnBrk="0" hangingPunct="1">
+      <a:defRPr sz="1200" kern="1200">
+        <a:solidFill>
+          <a:schemeClr val="tx1"/>
+        </a:solidFill>
+        <a:latin typeface="+mn-lt"/>
+        <a:ea typeface="+mn-ea"/>
+        <a:cs typeface="+mn-cs"/>
+      </a:defRPr>
+    </a:lvl8pPr>
+    <a:lvl9pPr marL="3657600" algn="l" defTabSz="914400" rtl="0" eaLnBrk="1" latinLnBrk="0" hangingPunct="1">
+      <a:defRPr sz="1200" kern="1200">
+        <a:solidFill>
+          <a:schemeClr val="tx1"/>
+        </a:solidFill>
+        <a:latin typeface="+mn-lt"/>
+        <a:ea typeface="+mn-ea"/>
+        <a:cs typeface="+mn-cs"/>
+      </a:defRPr>
+    </a:lvl9pPr>
+  </p:notesStyle>
+</p:notesMaster>
+</file>
+
+<file path=ppt/notesSlides/notesSlide1.xml><?xml version="1.0" encoding="utf-8"?>
+<p:notes xmlns:a="http://schemas.openxmlformats.org/drawingml/2006/main" xmlns:r="http://schemas.openxmlformats.org/officeDocument/2006/relationships" xmlns:p="http://schemas.openxmlformats.org/presentationml/2006/main">
+  <p:cSld>
+    <p:spTree>
+      <p:nvGrpSpPr>
+        <p:cNvPr id="1" name=""/>
+        <p:cNvGrpSpPr/>
+        <p:nvPr/>
+      </p:nvGrpSpPr>
+      <p:grpSpPr>
+        <a:xfrm>
+          <a:off x="0" y="0"/>
+          <a:ext cx="0" cy="0"/>
+          <a:chOff x="0" y="0"/>
+          <a:chExt cx="0" cy="0"/>
+        </a:xfrm>
+      </p:grpSpPr>
+      <p:sp>
+        <p:nvSpPr>
+          <p:cNvPr id="2" name="Folienbildplatzhalter 1"/>
+          <p:cNvSpPr>
+            <a:spLocks noGrp="1" noRot="1" noChangeAspect="1"/>
+          </p:cNvSpPr>
+          <p:nvPr>
+            <p:ph type="sldImg"/>
+          </p:nvPr>
+        </p:nvSpPr>
+        <p:spPr/>
+      </p:sp>
+      <p:sp>
+        <p:nvSpPr>
+          <p:cNvPr id="3" name="Notizenplatzhalter 2"/>
+          <p:cNvSpPr>
+            <a:spLocks noGrp="1"/>
+          </p:cNvSpPr>
+          <p:nvPr>
+            <p:ph type="body" idx="1"/>
+          </p:nvPr>
+        </p:nvSpPr>
+        <p:spPr/>
+        <p:txBody>
+          <a:bodyPr/>
+          <a:lstStyle/>
+          <a:p>
+            <a:endParaRPr lang="de-CH" dirty="0"/>
+          </a:p>
+        </p:txBody>
+      </p:sp>
+      <p:sp>
+        <p:nvSpPr>
+          <p:cNvPr id="4" name="Foliennummernplatzhalter 3"/>
+          <p:cNvSpPr>
+            <a:spLocks noGrp="1"/>
+          </p:cNvSpPr>
+          <p:nvPr>
+            <p:ph type="sldNum" sz="quarter" idx="5"/>
+          </p:nvPr>
+        </p:nvSpPr>
+        <p:spPr/>
+        <p:txBody>
+          <a:bodyPr/>
+          <a:lstStyle/>
+          <a:p>
+            <a:fld id="{0B4C1694-879D-4CEF-B0E1-3CF57A3A99BD}" type="slidenum">
+              <a:rPr lang="de-CH" smtClean="0"/>
+              <a:t>1</a:t>
+            </a:fld>
+            <a:endParaRPr lang="de-CH"/>
+          </a:p>
+        </p:txBody>
+      </p:sp>
+    </p:spTree>
+    <p:extLst>
+      <p:ext uri="{BB962C8B-B14F-4D97-AF65-F5344CB8AC3E}">
+        <p14:creationId xmlns:p14="http://schemas.microsoft.com/office/powerpoint/2010/main" val="1349825708"/>
+      </p:ext>
+    </p:extLst>
+  </p:cSld>
+  <p:clrMapOvr>
+    <a:masterClrMapping/>
+  </p:clrMapOvr>
+</p:notes>
 </file>
 
 <file path=ppt/slideLayouts/slideLayout1.xml><?xml version="1.0" encoding="utf-8"?>
@@ -262,7 +719,7 @@
           <a:p>
             <a:fld id="{732CB7D4-CFD6-4086-B0BB-696717916F0D}" type="datetimeFigureOut">
               <a:rPr lang="de-CH" smtClean="0"/>
-              <a:t>08.01.2026</a:t>
+              <a:t>09.01.2026</a:t>
             </a:fld>
             <a:endParaRPr lang="de-CH"/>
           </a:p>
@@ -462,7 +919,7 @@
           <a:p>
             <a:fld id="{732CB7D4-CFD6-4086-B0BB-696717916F0D}" type="datetimeFigureOut">
               <a:rPr lang="de-CH" smtClean="0"/>
-              <a:t>08.01.2026</a:t>
+              <a:t>09.01.2026</a:t>
             </a:fld>
             <a:endParaRPr lang="de-CH"/>
           </a:p>
@@ -672,7 +1129,7 @@
           <a:p>
             <a:fld id="{732CB7D4-CFD6-4086-B0BB-696717916F0D}" type="datetimeFigureOut">
               <a:rPr lang="de-CH" smtClean="0"/>
-              <a:t>08.01.2026</a:t>
+              <a:t>09.01.2026</a:t>
             </a:fld>
             <a:endParaRPr lang="de-CH"/>
           </a:p>
@@ -872,7 +1329,7 @@
           <a:p>
             <a:fld id="{732CB7D4-CFD6-4086-B0BB-696717916F0D}" type="datetimeFigureOut">
               <a:rPr lang="de-CH" smtClean="0"/>
-              <a:t>08.01.2026</a:t>
+              <a:t>09.01.2026</a:t>
             </a:fld>
             <a:endParaRPr lang="de-CH"/>
           </a:p>
@@ -1148,7 +1605,7 @@
           <a:p>
             <a:fld id="{732CB7D4-CFD6-4086-B0BB-696717916F0D}" type="datetimeFigureOut">
               <a:rPr lang="de-CH" smtClean="0"/>
-              <a:t>08.01.2026</a:t>
+              <a:t>09.01.2026</a:t>
             </a:fld>
             <a:endParaRPr lang="de-CH"/>
           </a:p>
@@ -1416,7 +1873,7 @@
           <a:p>
             <a:fld id="{732CB7D4-CFD6-4086-B0BB-696717916F0D}" type="datetimeFigureOut">
               <a:rPr lang="de-CH" smtClean="0"/>
-              <a:t>08.01.2026</a:t>
+              <a:t>09.01.2026</a:t>
             </a:fld>
             <a:endParaRPr lang="de-CH"/>
           </a:p>
@@ -1831,7 +2288,7 @@
           <a:p>
             <a:fld id="{732CB7D4-CFD6-4086-B0BB-696717916F0D}" type="datetimeFigureOut">
               <a:rPr lang="de-CH" smtClean="0"/>
-              <a:t>08.01.2026</a:t>
+              <a:t>09.01.2026</a:t>
             </a:fld>
             <a:endParaRPr lang="de-CH"/>
           </a:p>
@@ -1973,7 +2430,7 @@
           <a:p>
             <a:fld id="{732CB7D4-CFD6-4086-B0BB-696717916F0D}" type="datetimeFigureOut">
               <a:rPr lang="de-CH" smtClean="0"/>
-              <a:t>08.01.2026</a:t>
+              <a:t>09.01.2026</a:t>
             </a:fld>
             <a:endParaRPr lang="de-CH"/>
           </a:p>
@@ -2086,7 +2543,7 @@
           <a:p>
             <a:fld id="{732CB7D4-CFD6-4086-B0BB-696717916F0D}" type="datetimeFigureOut">
               <a:rPr lang="de-CH" smtClean="0"/>
-              <a:t>08.01.2026</a:t>
+              <a:t>09.01.2026</a:t>
             </a:fld>
             <a:endParaRPr lang="de-CH"/>
           </a:p>
@@ -2399,7 +2856,7 @@
           <a:p>
             <a:fld id="{732CB7D4-CFD6-4086-B0BB-696717916F0D}" type="datetimeFigureOut">
               <a:rPr lang="de-CH" smtClean="0"/>
-              <a:t>08.01.2026</a:t>
+              <a:t>09.01.2026</a:t>
             </a:fld>
             <a:endParaRPr lang="de-CH"/>
           </a:p>
@@ -2688,7 +3145,7 @@
           <a:p>
             <a:fld id="{732CB7D4-CFD6-4086-B0BB-696717916F0D}" type="datetimeFigureOut">
               <a:rPr lang="de-CH" smtClean="0"/>
-              <a:t>08.01.2026</a:t>
+              <a:t>09.01.2026</a:t>
             </a:fld>
             <a:endParaRPr lang="de-CH"/>
           </a:p>
@@ -2931,7 +3388,7 @@
           <a:p>
             <a:fld id="{732CB7D4-CFD6-4086-B0BB-696717916F0D}" type="datetimeFigureOut">
               <a:rPr lang="de-CH" smtClean="0"/>
-              <a:t>08.01.2026</a:t>
+              <a:t>09.01.2026</a:t>
             </a:fld>
             <a:endParaRPr lang="de-CH"/>
           </a:p>
@@ -3419,6 +3876,1575 @@
 </p:sld>
 </file>
 
+<file path=ppt/slides/slide10.xml><?xml version="1.0" encoding="utf-8"?>
+<p:sld xmlns:a="http://schemas.openxmlformats.org/drawingml/2006/main" xmlns:r="http://schemas.openxmlformats.org/officeDocument/2006/relationships" xmlns:p="http://schemas.openxmlformats.org/presentationml/2006/main">
+  <p:cSld>
+    <p:spTree>
+      <p:nvGrpSpPr>
+        <p:cNvPr id="1" name="">
+          <a:extLst>
+            <a:ext uri="{FF2B5EF4-FFF2-40B4-BE49-F238E27FC236}">
+              <a16:creationId xmlns:a16="http://schemas.microsoft.com/office/drawing/2014/main" id="{B6874CA6-6907-8639-2FB3-3E338E235876}"/>
+            </a:ext>
+          </a:extLst>
+        </p:cNvPr>
+        <p:cNvGrpSpPr/>
+        <p:nvPr/>
+      </p:nvGrpSpPr>
+      <p:grpSpPr>
+        <a:xfrm>
+          <a:off x="0" y="0"/>
+          <a:ext cx="0" cy="0"/>
+          <a:chOff x="0" y="0"/>
+          <a:chExt cx="0" cy="0"/>
+        </a:xfrm>
+      </p:grpSpPr>
+      <p:sp>
+        <p:nvSpPr>
+          <p:cNvPr id="2" name="Titel 1">
+            <a:extLst>
+              <a:ext uri="{FF2B5EF4-FFF2-40B4-BE49-F238E27FC236}">
+                <a16:creationId xmlns:a16="http://schemas.microsoft.com/office/drawing/2014/main" id="{63BD8187-EB25-B57D-146F-4015E841EC8F}"/>
+              </a:ext>
+            </a:extLst>
+          </p:cNvPr>
+          <p:cNvSpPr>
+            <a:spLocks noGrp="1"/>
+          </p:cNvSpPr>
+          <p:nvPr>
+            <p:ph type="title"/>
+          </p:nvPr>
+        </p:nvSpPr>
+        <p:spPr/>
+        <p:txBody>
+          <a:bodyPr/>
+          <a:lstStyle/>
+          <a:p>
+            <a:r>
+              <a:rPr lang="de-DE" dirty="0"/>
+              <a:t>Schriftlicher Teil - Fragen</a:t>
+            </a:r>
+            <a:endParaRPr lang="de-CH" dirty="0"/>
+          </a:p>
+        </p:txBody>
+      </p:sp>
+      <p:sp>
+        <p:nvSpPr>
+          <p:cNvPr id="3" name="Inhaltsplatzhalter 2">
+            <a:extLst>
+              <a:ext uri="{FF2B5EF4-FFF2-40B4-BE49-F238E27FC236}">
+                <a16:creationId xmlns:a16="http://schemas.microsoft.com/office/drawing/2014/main" id="{A5B208EA-4814-14B2-9E7E-2BBE3813560A}"/>
+              </a:ext>
+            </a:extLst>
+          </p:cNvPr>
+          <p:cNvSpPr>
+            <a:spLocks noGrp="1"/>
+          </p:cNvSpPr>
+          <p:nvPr>
+            <p:ph idx="1"/>
+          </p:nvPr>
+        </p:nvSpPr>
+        <p:spPr>
+          <a:xfrm>
+            <a:off x="651388" y="1837192"/>
+            <a:ext cx="10515600" cy="4351338"/>
+          </a:xfrm>
+        </p:spPr>
+        <p:txBody>
+          <a:bodyPr/>
+          <a:lstStyle/>
+          <a:p>
+            <a:r>
+              <a:rPr lang="de-DE" dirty="0"/>
+              <a:t>Wieviel Wissen darf</a:t>
+            </a:r>
+          </a:p>
+          <a:p>
+            <a:pPr marL="0" indent="0">
+              <a:buNone/>
+            </a:pPr>
+            <a:r>
+              <a:rPr lang="de-DE" dirty="0"/>
+              <a:t>ich annehmen?</a:t>
+            </a:r>
+          </a:p>
+          <a:p>
+            <a:r>
+              <a:rPr lang="de-DE" dirty="0" err="1"/>
+              <a:t>Vulnerability</a:t>
+            </a:r>
+            <a:r>
+              <a:rPr lang="de-DE" dirty="0"/>
+              <a:t> immer</a:t>
+            </a:r>
+          </a:p>
+          <a:p>
+            <a:pPr marL="0" indent="0">
+              <a:buNone/>
+            </a:pPr>
+            <a:r>
+              <a:rPr lang="de-DE" dirty="0"/>
+              <a:t>noch im Detail erklären?</a:t>
+            </a:r>
+          </a:p>
+          <a:p>
+            <a:pPr marL="0" indent="0">
+              <a:buNone/>
+            </a:pPr>
+            <a:endParaRPr lang="de-CH" dirty="0"/>
+          </a:p>
+        </p:txBody>
+      </p:sp>
+      <p:pic>
+        <p:nvPicPr>
+          <p:cNvPr id="6" name="Grafik 5">
+            <a:extLst>
+              <a:ext uri="{FF2B5EF4-FFF2-40B4-BE49-F238E27FC236}">
+                <a16:creationId xmlns:a16="http://schemas.microsoft.com/office/drawing/2014/main" id="{315D6CCA-E368-2501-C22E-D3E66EFF72EF}"/>
+              </a:ext>
+            </a:extLst>
+          </p:cNvPr>
+          <p:cNvPicPr>
+            <a:picLocks noChangeAspect="1"/>
+          </p:cNvPicPr>
+          <p:nvPr/>
+        </p:nvPicPr>
+        <p:blipFill>
+          <a:blip r:embed="rId2"/>
+          <a:stretch>
+            <a:fillRect/>
+          </a:stretch>
+        </p:blipFill>
+        <p:spPr>
+          <a:xfrm>
+            <a:off x="4646578" y="511629"/>
+            <a:ext cx="7378508" cy="6186948"/>
+          </a:xfrm>
+          <a:prstGeom prst="rect">
+            <a:avLst/>
+          </a:prstGeom>
+        </p:spPr>
+      </p:pic>
+    </p:spTree>
+    <p:extLst>
+      <p:ext uri="{BB962C8B-B14F-4D97-AF65-F5344CB8AC3E}">
+        <p14:creationId xmlns:p14="http://schemas.microsoft.com/office/powerpoint/2010/main" val="3291548602"/>
+      </p:ext>
+    </p:extLst>
+  </p:cSld>
+  <p:clrMapOvr>
+    <a:masterClrMapping/>
+  </p:clrMapOvr>
+</p:sld>
+</file>
+
+<file path=ppt/slides/slide11.xml><?xml version="1.0" encoding="utf-8"?>
+<p:sld xmlns:a="http://schemas.openxmlformats.org/drawingml/2006/main" xmlns:r="http://schemas.openxmlformats.org/officeDocument/2006/relationships" xmlns:p="http://schemas.openxmlformats.org/presentationml/2006/main">
+  <p:cSld>
+    <p:spTree>
+      <p:nvGrpSpPr>
+        <p:cNvPr id="1" name=""/>
+        <p:cNvGrpSpPr/>
+        <p:nvPr/>
+      </p:nvGrpSpPr>
+      <p:grpSpPr>
+        <a:xfrm>
+          <a:off x="0" y="0"/>
+          <a:ext cx="0" cy="0"/>
+          <a:chOff x="0" y="0"/>
+          <a:chExt cx="0" cy="0"/>
+        </a:xfrm>
+      </p:grpSpPr>
+      <p:sp>
+        <p:nvSpPr>
+          <p:cNvPr id="2" name="Titel 1">
+            <a:extLst>
+              <a:ext uri="{FF2B5EF4-FFF2-40B4-BE49-F238E27FC236}">
+                <a16:creationId xmlns:a16="http://schemas.microsoft.com/office/drawing/2014/main" id="{45BF94AF-E3A1-A198-784F-CA62E40A0AE2}"/>
+              </a:ext>
+            </a:extLst>
+          </p:cNvPr>
+          <p:cNvSpPr>
+            <a:spLocks noGrp="1"/>
+          </p:cNvSpPr>
+          <p:nvPr>
+            <p:ph type="title"/>
+          </p:nvPr>
+        </p:nvSpPr>
+        <p:spPr/>
+        <p:txBody>
+          <a:bodyPr/>
+          <a:lstStyle/>
+          <a:p>
+            <a:r>
+              <a:rPr lang="de-DE" dirty="0"/>
+              <a:t>Clean </a:t>
+            </a:r>
+            <a:r>
+              <a:rPr lang="de-DE" dirty="0" err="1"/>
+              <a:t>up</a:t>
+            </a:r>
+            <a:r>
+              <a:rPr lang="de-DE" dirty="0"/>
+              <a:t> </a:t>
+            </a:r>
+            <a:r>
+              <a:rPr lang="de-DE" dirty="0" err="1"/>
+              <a:t>project</a:t>
+            </a:r>
+            <a:r>
+              <a:rPr lang="de-DE" dirty="0"/>
+              <a:t> code</a:t>
+            </a:r>
+            <a:endParaRPr lang="de-CH" dirty="0"/>
+          </a:p>
+        </p:txBody>
+      </p:sp>
+      <p:sp>
+        <p:nvSpPr>
+          <p:cNvPr id="3" name="Inhaltsplatzhalter 2">
+            <a:extLst>
+              <a:ext uri="{FF2B5EF4-FFF2-40B4-BE49-F238E27FC236}">
+                <a16:creationId xmlns:a16="http://schemas.microsoft.com/office/drawing/2014/main" id="{42244927-C4C6-B0EB-94D4-DE4C831BAE1D}"/>
+              </a:ext>
+            </a:extLst>
+          </p:cNvPr>
+          <p:cNvSpPr>
+            <a:spLocks noGrp="1"/>
+          </p:cNvSpPr>
+          <p:nvPr>
+            <p:ph idx="1"/>
+          </p:nvPr>
+        </p:nvSpPr>
+        <p:spPr/>
+        <p:txBody>
+          <a:bodyPr/>
+          <a:lstStyle/>
+          <a:p>
+            <a:r>
+              <a:rPr lang="de-DE" dirty="0" err="1"/>
+              <a:t>Refactoring</a:t>
+            </a:r>
+            <a:endParaRPr lang="de-DE" dirty="0"/>
+          </a:p>
+          <a:p>
+            <a:r>
+              <a:rPr lang="de-DE" dirty="0" err="1"/>
+              <a:t>Docstrings</a:t>
+            </a:r>
+            <a:endParaRPr lang="de-DE" dirty="0"/>
+          </a:p>
+          <a:p>
+            <a:r>
+              <a:rPr lang="de-DE" dirty="0"/>
+              <a:t>Coding </a:t>
+            </a:r>
+            <a:r>
+              <a:rPr lang="de-DE" dirty="0" err="1"/>
+              <a:t>standard</a:t>
+            </a:r>
+            <a:endParaRPr lang="de-DE" dirty="0"/>
+          </a:p>
+          <a:p>
+            <a:r>
+              <a:rPr lang="de-DE" dirty="0" err="1"/>
+              <a:t>How</a:t>
+            </a:r>
+            <a:r>
+              <a:rPr lang="de-DE" dirty="0"/>
+              <a:t> </a:t>
+            </a:r>
+            <a:r>
+              <a:rPr lang="de-DE" dirty="0" err="1"/>
+              <a:t>to</a:t>
+            </a:r>
+            <a:r>
+              <a:rPr lang="de-DE" dirty="0"/>
+              <a:t> </a:t>
+            </a:r>
+            <a:r>
+              <a:rPr lang="de-DE" dirty="0" err="1"/>
+              <a:t>contribute</a:t>
+            </a:r>
+            <a:endParaRPr lang="de-CH" dirty="0"/>
+          </a:p>
+        </p:txBody>
+      </p:sp>
+      <p:pic>
+        <p:nvPicPr>
+          <p:cNvPr id="5" name="Grafik 4">
+            <a:extLst>
+              <a:ext uri="{FF2B5EF4-FFF2-40B4-BE49-F238E27FC236}">
+                <a16:creationId xmlns:a16="http://schemas.microsoft.com/office/drawing/2014/main" id="{520527F8-F67B-66C9-724C-9711E1D63E5E}"/>
+              </a:ext>
+            </a:extLst>
+          </p:cNvPr>
+          <p:cNvPicPr>
+            <a:picLocks noChangeAspect="1"/>
+          </p:cNvPicPr>
+          <p:nvPr/>
+        </p:nvPicPr>
+        <p:blipFill>
+          <a:blip r:embed="rId2"/>
+          <a:stretch>
+            <a:fillRect/>
+          </a:stretch>
+        </p:blipFill>
+        <p:spPr>
+          <a:xfrm>
+            <a:off x="6096000" y="905797"/>
+            <a:ext cx="5867400" cy="5715000"/>
+          </a:xfrm>
+          <a:prstGeom prst="rect">
+            <a:avLst/>
+          </a:prstGeom>
+        </p:spPr>
+      </p:pic>
+    </p:spTree>
+    <p:extLst>
+      <p:ext uri="{BB962C8B-B14F-4D97-AF65-F5344CB8AC3E}">
+        <p14:creationId xmlns:p14="http://schemas.microsoft.com/office/powerpoint/2010/main" val="2853378767"/>
+      </p:ext>
+    </p:extLst>
+  </p:cSld>
+  <p:clrMapOvr>
+    <a:masterClrMapping/>
+  </p:clrMapOvr>
+</p:sld>
+</file>
+
+<file path=ppt/slides/slide12.xml><?xml version="1.0" encoding="utf-8"?>
+<p:sld xmlns:a="http://schemas.openxmlformats.org/drawingml/2006/main" xmlns:r="http://schemas.openxmlformats.org/officeDocument/2006/relationships" xmlns:p="http://schemas.openxmlformats.org/presentationml/2006/main">
+  <p:cSld>
+    <p:spTree>
+      <p:nvGrpSpPr>
+        <p:cNvPr id="1" name="">
+          <a:extLst>
+            <a:ext uri="{FF2B5EF4-FFF2-40B4-BE49-F238E27FC236}">
+              <a16:creationId xmlns:a16="http://schemas.microsoft.com/office/drawing/2014/main" id="{DA63C2D6-F433-3B50-9025-66ED70F18EC8}"/>
+            </a:ext>
+          </a:extLst>
+        </p:cNvPr>
+        <p:cNvGrpSpPr/>
+        <p:nvPr/>
+      </p:nvGrpSpPr>
+      <p:grpSpPr>
+        <a:xfrm>
+          <a:off x="0" y="0"/>
+          <a:ext cx="0" cy="0"/>
+          <a:chOff x="0" y="0"/>
+          <a:chExt cx="0" cy="0"/>
+        </a:xfrm>
+      </p:grpSpPr>
+      <p:sp>
+        <p:nvSpPr>
+          <p:cNvPr id="2" name="Titel 1">
+            <a:extLst>
+              <a:ext uri="{FF2B5EF4-FFF2-40B4-BE49-F238E27FC236}">
+                <a16:creationId xmlns:a16="http://schemas.microsoft.com/office/drawing/2014/main" id="{3B90062E-56D1-AD1E-9A2A-9EA3546ED7AB}"/>
+              </a:ext>
+            </a:extLst>
+          </p:cNvPr>
+          <p:cNvSpPr>
+            <a:spLocks noGrp="1"/>
+          </p:cNvSpPr>
+          <p:nvPr>
+            <p:ph type="title"/>
+          </p:nvPr>
+        </p:nvSpPr>
+        <p:spPr/>
+        <p:txBody>
+          <a:bodyPr/>
+          <a:lstStyle/>
+          <a:p>
+            <a:r>
+              <a:rPr lang="de-DE" dirty="0" err="1"/>
+              <a:t>APK‘s</a:t>
+            </a:r>
+            <a:r>
+              <a:rPr lang="de-DE" dirty="0"/>
+              <a:t> Problem</a:t>
+            </a:r>
+            <a:endParaRPr lang="de-CH" dirty="0"/>
+          </a:p>
+        </p:txBody>
+      </p:sp>
+      <p:sp>
+        <p:nvSpPr>
+          <p:cNvPr id="3" name="Inhaltsplatzhalter 2">
+            <a:extLst>
+              <a:ext uri="{FF2B5EF4-FFF2-40B4-BE49-F238E27FC236}">
+                <a16:creationId xmlns:a16="http://schemas.microsoft.com/office/drawing/2014/main" id="{88B6CF1D-85B4-4495-D41B-B0AEAB1BCE0F}"/>
+              </a:ext>
+            </a:extLst>
+          </p:cNvPr>
+          <p:cNvSpPr>
+            <a:spLocks noGrp="1"/>
+          </p:cNvSpPr>
+          <p:nvPr>
+            <p:ph idx="1"/>
+          </p:nvPr>
+        </p:nvSpPr>
+        <p:spPr/>
+        <p:txBody>
+          <a:bodyPr/>
+          <a:lstStyle/>
+          <a:p>
+            <a:r>
+              <a:rPr lang="de-DE" dirty="0"/>
+              <a:t>Momentan modulare Struktur </a:t>
+            </a:r>
+          </a:p>
+          <a:p>
+            <a:pPr>
+              <a:buFont typeface="Wingdings" panose="05000000000000000000" pitchFamily="2" charset="2"/>
+              <a:buChar char="è"/>
+            </a:pPr>
+            <a:r>
+              <a:rPr lang="de-DE" dirty="0" err="1"/>
+              <a:t>Seperate</a:t>
+            </a:r>
+            <a:r>
+              <a:rPr lang="de-DE" dirty="0"/>
+              <a:t> </a:t>
+            </a:r>
+            <a:r>
+              <a:rPr lang="de-DE" dirty="0" err="1"/>
+              <a:t>APK‘s</a:t>
+            </a:r>
+            <a:r>
+              <a:rPr lang="de-DE" dirty="0"/>
+              <a:t> </a:t>
+            </a:r>
+            <a:r>
+              <a:rPr lang="de-DE" dirty="0">
+                <a:sym typeface="Wingdings" panose="05000000000000000000" pitchFamily="2" charset="2"/>
+              </a:rPr>
+              <a:t></a:t>
+            </a:r>
+          </a:p>
+          <a:p>
+            <a:pPr marL="0" indent="0">
+              <a:buNone/>
+            </a:pPr>
+            <a:endParaRPr lang="de-DE" dirty="0">
+              <a:sym typeface="Wingdings" panose="05000000000000000000" pitchFamily="2" charset="2"/>
+            </a:endParaRPr>
+          </a:p>
+          <a:p>
+            <a:pPr marL="0" indent="0">
+              <a:buNone/>
+            </a:pPr>
+            <a:r>
+              <a:rPr lang="de-DE" dirty="0">
+                <a:sym typeface="Wingdings" panose="05000000000000000000" pitchFamily="2" charset="2"/>
+              </a:rPr>
+              <a:t>1 APK = 1 </a:t>
+            </a:r>
+            <a:r>
+              <a:rPr lang="de-DE" dirty="0" err="1">
+                <a:sym typeface="Wingdings" panose="05000000000000000000" pitchFamily="2" charset="2"/>
+              </a:rPr>
+              <a:t>AndroidManifest</a:t>
+            </a:r>
+            <a:endParaRPr lang="de-DE" dirty="0"/>
+          </a:p>
+          <a:p>
+            <a:endParaRPr lang="de-CH" dirty="0"/>
+          </a:p>
+        </p:txBody>
+      </p:sp>
+      <p:pic>
+        <p:nvPicPr>
+          <p:cNvPr id="5" name="Grafik 4">
+            <a:extLst>
+              <a:ext uri="{FF2B5EF4-FFF2-40B4-BE49-F238E27FC236}">
+                <a16:creationId xmlns:a16="http://schemas.microsoft.com/office/drawing/2014/main" id="{7D1C5601-BEF4-3803-B114-FCC7FE125158}"/>
+              </a:ext>
+            </a:extLst>
+          </p:cNvPr>
+          <p:cNvPicPr>
+            <a:picLocks noChangeAspect="1"/>
+          </p:cNvPicPr>
+          <p:nvPr/>
+        </p:nvPicPr>
+        <p:blipFill>
+          <a:blip r:embed="rId2"/>
+          <a:stretch>
+            <a:fillRect/>
+          </a:stretch>
+        </p:blipFill>
+        <p:spPr>
+          <a:xfrm>
+            <a:off x="5762203" y="569460"/>
+            <a:ext cx="6258413" cy="5025798"/>
+          </a:xfrm>
+          <a:prstGeom prst="rect">
+            <a:avLst/>
+          </a:prstGeom>
+        </p:spPr>
+      </p:pic>
+    </p:spTree>
+    <p:extLst>
+      <p:ext uri="{BB962C8B-B14F-4D97-AF65-F5344CB8AC3E}">
+        <p14:creationId xmlns:p14="http://schemas.microsoft.com/office/powerpoint/2010/main" val="1852411550"/>
+      </p:ext>
+    </p:extLst>
+  </p:cSld>
+  <p:clrMapOvr>
+    <a:masterClrMapping/>
+  </p:clrMapOvr>
+</p:sld>
+</file>
+
+<file path=ppt/slides/slide13.xml><?xml version="1.0" encoding="utf-8"?>
+<p:sld xmlns:a="http://schemas.openxmlformats.org/drawingml/2006/main" xmlns:r="http://schemas.openxmlformats.org/officeDocument/2006/relationships" xmlns:p="http://schemas.openxmlformats.org/presentationml/2006/main">
+  <p:cSld>
+    <p:spTree>
+      <p:nvGrpSpPr>
+        <p:cNvPr id="1" name="">
+          <a:extLst>
+            <a:ext uri="{FF2B5EF4-FFF2-40B4-BE49-F238E27FC236}">
+              <a16:creationId xmlns:a16="http://schemas.microsoft.com/office/drawing/2014/main" id="{97BBAEE7-A5C2-8640-6FFB-51DD122F9C3A}"/>
+            </a:ext>
+          </a:extLst>
+        </p:cNvPr>
+        <p:cNvGrpSpPr/>
+        <p:nvPr/>
+      </p:nvGrpSpPr>
+      <p:grpSpPr>
+        <a:xfrm>
+          <a:off x="0" y="0"/>
+          <a:ext cx="0" cy="0"/>
+          <a:chOff x="0" y="0"/>
+          <a:chExt cx="0" cy="0"/>
+        </a:xfrm>
+      </p:grpSpPr>
+      <p:sp>
+        <p:nvSpPr>
+          <p:cNvPr id="2" name="Titel 1">
+            <a:extLst>
+              <a:ext uri="{FF2B5EF4-FFF2-40B4-BE49-F238E27FC236}">
+                <a16:creationId xmlns:a16="http://schemas.microsoft.com/office/drawing/2014/main" id="{BC5ED9D4-D169-06F8-1A91-D08D6FA8ED65}"/>
+              </a:ext>
+            </a:extLst>
+          </p:cNvPr>
+          <p:cNvSpPr>
+            <a:spLocks noGrp="1"/>
+          </p:cNvSpPr>
+          <p:nvPr>
+            <p:ph type="title"/>
+          </p:nvPr>
+        </p:nvSpPr>
+        <p:spPr/>
+        <p:txBody>
+          <a:bodyPr/>
+          <a:lstStyle/>
+          <a:p>
+            <a:r>
+              <a:rPr lang="de-DE" dirty="0"/>
+              <a:t>Templates</a:t>
+            </a:r>
+            <a:endParaRPr lang="de-CH" dirty="0"/>
+          </a:p>
+        </p:txBody>
+      </p:sp>
+      <p:sp>
+        <p:nvSpPr>
+          <p:cNvPr id="3" name="Inhaltsplatzhalter 2">
+            <a:extLst>
+              <a:ext uri="{FF2B5EF4-FFF2-40B4-BE49-F238E27FC236}">
+                <a16:creationId xmlns:a16="http://schemas.microsoft.com/office/drawing/2014/main" id="{6ED84B78-FD95-01B5-9B63-3AD2002600D6}"/>
+              </a:ext>
+            </a:extLst>
+          </p:cNvPr>
+          <p:cNvSpPr>
+            <a:spLocks noGrp="1"/>
+          </p:cNvSpPr>
+          <p:nvPr>
+            <p:ph idx="1"/>
+          </p:nvPr>
+        </p:nvSpPr>
+        <p:spPr>
+          <a:xfrm>
+            <a:off x="838200" y="1782082"/>
+            <a:ext cx="10515600" cy="4351338"/>
+          </a:xfrm>
+        </p:spPr>
+        <p:txBody>
+          <a:bodyPr/>
+          <a:lstStyle/>
+          <a:p>
+            <a:pPr marL="0" indent="0">
+              <a:buNone/>
+            </a:pPr>
+            <a:r>
+              <a:rPr lang="de-DE" dirty="0"/>
+              <a:t>Flow für alle Templates</a:t>
+            </a:r>
+            <a:endParaRPr lang="de-CH" dirty="0"/>
+          </a:p>
+        </p:txBody>
+      </p:sp>
+      <p:pic>
+        <p:nvPicPr>
+          <p:cNvPr id="6" name="Grafik 5">
+            <a:extLst>
+              <a:ext uri="{FF2B5EF4-FFF2-40B4-BE49-F238E27FC236}">
+                <a16:creationId xmlns:a16="http://schemas.microsoft.com/office/drawing/2014/main" id="{F8B28803-FC3E-6830-0909-8DF57E62D816}"/>
+              </a:ext>
+            </a:extLst>
+          </p:cNvPr>
+          <p:cNvPicPr>
+            <a:picLocks noChangeAspect="1"/>
+          </p:cNvPicPr>
+          <p:nvPr/>
+        </p:nvPicPr>
+        <p:blipFill>
+          <a:blip r:embed="rId2"/>
+          <a:stretch>
+            <a:fillRect/>
+          </a:stretch>
+        </p:blipFill>
+        <p:spPr>
+          <a:xfrm>
+            <a:off x="4478365" y="-365125"/>
+            <a:ext cx="7472745" cy="6858000"/>
+          </a:xfrm>
+          <a:prstGeom prst="rect">
+            <a:avLst/>
+          </a:prstGeom>
+        </p:spPr>
+      </p:pic>
+    </p:spTree>
+    <p:extLst>
+      <p:ext uri="{BB962C8B-B14F-4D97-AF65-F5344CB8AC3E}">
+        <p14:creationId xmlns:p14="http://schemas.microsoft.com/office/powerpoint/2010/main" val="473984050"/>
+      </p:ext>
+    </p:extLst>
+  </p:cSld>
+  <p:clrMapOvr>
+    <a:masterClrMapping/>
+  </p:clrMapOvr>
+</p:sld>
+</file>
+
+<file path=ppt/slides/slide14.xml><?xml version="1.0" encoding="utf-8"?>
+<p:sld xmlns:a="http://schemas.openxmlformats.org/drawingml/2006/main" xmlns:r="http://schemas.openxmlformats.org/officeDocument/2006/relationships" xmlns:p="http://schemas.openxmlformats.org/presentationml/2006/main">
+  <p:cSld>
+    <p:spTree>
+      <p:nvGrpSpPr>
+        <p:cNvPr id="1" name="">
+          <a:extLst>
+            <a:ext uri="{FF2B5EF4-FFF2-40B4-BE49-F238E27FC236}">
+              <a16:creationId xmlns:a16="http://schemas.microsoft.com/office/drawing/2014/main" id="{216B03D6-899F-DDF7-B4D7-F4E36405BC14}"/>
+            </a:ext>
+          </a:extLst>
+        </p:cNvPr>
+        <p:cNvGrpSpPr/>
+        <p:nvPr/>
+      </p:nvGrpSpPr>
+      <p:grpSpPr>
+        <a:xfrm>
+          <a:off x="0" y="0"/>
+          <a:ext cx="0" cy="0"/>
+          <a:chOff x="0" y="0"/>
+          <a:chExt cx="0" cy="0"/>
+        </a:xfrm>
+      </p:grpSpPr>
+      <p:sp>
+        <p:nvSpPr>
+          <p:cNvPr id="2" name="Titel 1">
+            <a:extLst>
+              <a:ext uri="{FF2B5EF4-FFF2-40B4-BE49-F238E27FC236}">
+                <a16:creationId xmlns:a16="http://schemas.microsoft.com/office/drawing/2014/main" id="{25AA9DD3-E7CA-EE7D-4159-B63407978589}"/>
+              </a:ext>
+            </a:extLst>
+          </p:cNvPr>
+          <p:cNvSpPr>
+            <a:spLocks noGrp="1"/>
+          </p:cNvSpPr>
+          <p:nvPr>
+            <p:ph type="title"/>
+          </p:nvPr>
+        </p:nvSpPr>
+        <p:spPr/>
+        <p:txBody>
+          <a:bodyPr/>
+          <a:lstStyle/>
+          <a:p>
+            <a:r>
+              <a:rPr lang="de-DE" dirty="0" err="1"/>
+              <a:t>Comparison</a:t>
+            </a:r>
+            <a:r>
+              <a:rPr lang="de-DE" dirty="0"/>
+              <a:t> </a:t>
+            </a:r>
+            <a:r>
+              <a:rPr lang="de-DE" dirty="0" err="1"/>
+              <a:t>existing</a:t>
+            </a:r>
+            <a:r>
+              <a:rPr lang="de-DE" dirty="0"/>
+              <a:t> </a:t>
+            </a:r>
+            <a:r>
+              <a:rPr lang="de-DE" dirty="0" err="1"/>
+              <a:t>apps</a:t>
+            </a:r>
+            <a:endParaRPr lang="de-CH" dirty="0"/>
+          </a:p>
+        </p:txBody>
+      </p:sp>
+      <p:sp>
+        <p:nvSpPr>
+          <p:cNvPr id="3" name="Inhaltsplatzhalter 2">
+            <a:extLst>
+              <a:ext uri="{FF2B5EF4-FFF2-40B4-BE49-F238E27FC236}">
+                <a16:creationId xmlns:a16="http://schemas.microsoft.com/office/drawing/2014/main" id="{57E981B8-71CB-0B81-3952-4DFA1D136BC3}"/>
+              </a:ext>
+            </a:extLst>
+          </p:cNvPr>
+          <p:cNvSpPr>
+            <a:spLocks noGrp="1"/>
+          </p:cNvSpPr>
+          <p:nvPr>
+            <p:ph idx="1"/>
+          </p:nvPr>
+        </p:nvSpPr>
+        <p:spPr/>
+        <p:txBody>
+          <a:bodyPr/>
+          <a:lstStyle/>
+          <a:p>
+            <a:r>
+              <a:rPr lang="de-DE" dirty="0"/>
+              <a:t>Prozentual</a:t>
+            </a:r>
+            <a:endParaRPr lang="de-CH" dirty="0"/>
+          </a:p>
+          <a:p>
+            <a:endParaRPr lang="de-DE" dirty="0"/>
+          </a:p>
+          <a:p>
+            <a:endParaRPr lang="de-CH" dirty="0"/>
+          </a:p>
+        </p:txBody>
+      </p:sp>
+      <p:pic>
+        <p:nvPicPr>
+          <p:cNvPr id="7" name="Grafik 6" descr="Ein Bild, das Text, Screenshot, Diagramm, Schrift enthält.&#10;&#10;KI-generierte Inhalte können fehlerhaft sein.">
+            <a:extLst>
+              <a:ext uri="{FF2B5EF4-FFF2-40B4-BE49-F238E27FC236}">
+                <a16:creationId xmlns:a16="http://schemas.microsoft.com/office/drawing/2014/main" id="{73A97BCB-48CD-B65E-66EC-B9D63E815BBC}"/>
+              </a:ext>
+            </a:extLst>
+          </p:cNvPr>
+          <p:cNvPicPr>
+            <a:picLocks noChangeAspect="1"/>
+          </p:cNvPicPr>
+          <p:nvPr/>
+        </p:nvPicPr>
+        <p:blipFill>
+          <a:blip r:embed="rId2">
+            <a:extLst>
+              <a:ext uri="{28A0092B-C50C-407E-A947-70E740481C1C}">
+                <a14:useLocalDpi xmlns:a14="http://schemas.microsoft.com/office/drawing/2010/main" val="0"/>
+              </a:ext>
+            </a:extLst>
+          </a:blip>
+          <a:stretch>
+            <a:fillRect/>
+          </a:stretch>
+        </p:blipFill>
+        <p:spPr>
+          <a:xfrm>
+            <a:off x="4148313" y="1825625"/>
+            <a:ext cx="7205487" cy="4462281"/>
+          </a:xfrm>
+          <a:prstGeom prst="rect">
+            <a:avLst/>
+          </a:prstGeom>
+        </p:spPr>
+      </p:pic>
+    </p:spTree>
+    <p:extLst>
+      <p:ext uri="{BB962C8B-B14F-4D97-AF65-F5344CB8AC3E}">
+        <p14:creationId xmlns:p14="http://schemas.microsoft.com/office/powerpoint/2010/main" val="3946906491"/>
+      </p:ext>
+    </p:extLst>
+  </p:cSld>
+  <p:clrMapOvr>
+    <a:masterClrMapping/>
+  </p:clrMapOvr>
+</p:sld>
+</file>
+
+<file path=ppt/slides/slide15.xml><?xml version="1.0" encoding="utf-8"?>
+<p:sld xmlns:a="http://schemas.openxmlformats.org/drawingml/2006/main" xmlns:r="http://schemas.openxmlformats.org/officeDocument/2006/relationships" xmlns:p="http://schemas.openxmlformats.org/presentationml/2006/main">
+  <p:cSld>
+    <p:spTree>
+      <p:nvGrpSpPr>
+        <p:cNvPr id="1" name="">
+          <a:extLst>
+            <a:ext uri="{FF2B5EF4-FFF2-40B4-BE49-F238E27FC236}">
+              <a16:creationId xmlns:a16="http://schemas.microsoft.com/office/drawing/2014/main" id="{3736CAC0-1ED2-8293-CFD0-7DDADE5247DF}"/>
+            </a:ext>
+          </a:extLst>
+        </p:cNvPr>
+        <p:cNvGrpSpPr/>
+        <p:nvPr/>
+      </p:nvGrpSpPr>
+      <p:grpSpPr>
+        <a:xfrm>
+          <a:off x="0" y="0"/>
+          <a:ext cx="0" cy="0"/>
+          <a:chOff x="0" y="0"/>
+          <a:chExt cx="0" cy="0"/>
+        </a:xfrm>
+      </p:grpSpPr>
+      <p:sp>
+        <p:nvSpPr>
+          <p:cNvPr id="2" name="Titel 1">
+            <a:extLst>
+              <a:ext uri="{FF2B5EF4-FFF2-40B4-BE49-F238E27FC236}">
+                <a16:creationId xmlns:a16="http://schemas.microsoft.com/office/drawing/2014/main" id="{5B5186D3-C5B6-0DE9-939A-50120F30DDF1}"/>
+              </a:ext>
+            </a:extLst>
+          </p:cNvPr>
+          <p:cNvSpPr>
+            <a:spLocks noGrp="1"/>
+          </p:cNvSpPr>
+          <p:nvPr>
+            <p:ph type="title"/>
+          </p:nvPr>
+        </p:nvSpPr>
+        <p:spPr/>
+        <p:txBody>
+          <a:bodyPr/>
+          <a:lstStyle/>
+          <a:p>
+            <a:r>
+              <a:rPr lang="de-DE" dirty="0" err="1"/>
+              <a:t>Comparison</a:t>
+            </a:r>
+            <a:r>
+              <a:rPr lang="de-DE" dirty="0"/>
+              <a:t> </a:t>
+            </a:r>
+            <a:r>
+              <a:rPr lang="de-DE" dirty="0" err="1"/>
+              <a:t>existing</a:t>
+            </a:r>
+            <a:r>
+              <a:rPr lang="de-DE" dirty="0"/>
+              <a:t> </a:t>
+            </a:r>
+            <a:r>
+              <a:rPr lang="de-DE" dirty="0" err="1"/>
+              <a:t>apps</a:t>
+            </a:r>
+            <a:endParaRPr lang="de-CH" dirty="0"/>
+          </a:p>
+        </p:txBody>
+      </p:sp>
+      <p:sp>
+        <p:nvSpPr>
+          <p:cNvPr id="3" name="Inhaltsplatzhalter 2">
+            <a:extLst>
+              <a:ext uri="{FF2B5EF4-FFF2-40B4-BE49-F238E27FC236}">
+                <a16:creationId xmlns:a16="http://schemas.microsoft.com/office/drawing/2014/main" id="{816DD642-8307-74A7-6D98-B439A9E9CB14}"/>
+              </a:ext>
+            </a:extLst>
+          </p:cNvPr>
+          <p:cNvSpPr>
+            <a:spLocks noGrp="1"/>
+          </p:cNvSpPr>
+          <p:nvPr>
+            <p:ph idx="1"/>
+          </p:nvPr>
+        </p:nvSpPr>
+        <p:spPr/>
+        <p:txBody>
+          <a:bodyPr/>
+          <a:lstStyle/>
+          <a:p>
+            <a:r>
+              <a:rPr lang="de-DE" dirty="0"/>
+              <a:t>Prozentual</a:t>
+            </a:r>
+            <a:endParaRPr lang="de-CH" dirty="0"/>
+          </a:p>
+          <a:p>
+            <a:endParaRPr lang="de-DE" dirty="0"/>
+          </a:p>
+          <a:p>
+            <a:endParaRPr lang="de-CH" dirty="0"/>
+          </a:p>
+        </p:txBody>
+      </p:sp>
+      <p:pic>
+        <p:nvPicPr>
+          <p:cNvPr id="5" name="Grafik 4" descr="Ein Bild, das Text, Screenshot, Schrift, Diagramm enthält.&#10;&#10;KI-generierte Inhalte können fehlerhaft sein.">
+            <a:extLst>
+              <a:ext uri="{FF2B5EF4-FFF2-40B4-BE49-F238E27FC236}">
+                <a16:creationId xmlns:a16="http://schemas.microsoft.com/office/drawing/2014/main" id="{203D57D9-458B-33FD-3D2A-8AFBA9341C15}"/>
+              </a:ext>
+            </a:extLst>
+          </p:cNvPr>
+          <p:cNvPicPr>
+            <a:picLocks noChangeAspect="1"/>
+          </p:cNvPicPr>
+          <p:nvPr/>
+        </p:nvPicPr>
+        <p:blipFill>
+          <a:blip r:embed="rId2">
+            <a:extLst>
+              <a:ext uri="{28A0092B-C50C-407E-A947-70E740481C1C}">
+                <a14:useLocalDpi xmlns:a14="http://schemas.microsoft.com/office/drawing/2010/main" val="0"/>
+              </a:ext>
+            </a:extLst>
+          </a:blip>
+          <a:stretch>
+            <a:fillRect/>
+          </a:stretch>
+        </p:blipFill>
+        <p:spPr>
+          <a:xfrm>
+            <a:off x="4148313" y="1825625"/>
+            <a:ext cx="7205487" cy="4462281"/>
+          </a:xfrm>
+          <a:prstGeom prst="rect">
+            <a:avLst/>
+          </a:prstGeom>
+        </p:spPr>
+      </p:pic>
+    </p:spTree>
+    <p:extLst>
+      <p:ext uri="{BB962C8B-B14F-4D97-AF65-F5344CB8AC3E}">
+        <p14:creationId xmlns:p14="http://schemas.microsoft.com/office/powerpoint/2010/main" val="2438397135"/>
+      </p:ext>
+    </p:extLst>
+  </p:cSld>
+  <p:clrMapOvr>
+    <a:masterClrMapping/>
+  </p:clrMapOvr>
+</p:sld>
+</file>
+
+<file path=ppt/slides/slide16.xml><?xml version="1.0" encoding="utf-8"?>
+<p:sld xmlns:a="http://schemas.openxmlformats.org/drawingml/2006/main" xmlns:r="http://schemas.openxmlformats.org/officeDocument/2006/relationships" xmlns:p="http://schemas.openxmlformats.org/presentationml/2006/main">
+  <p:cSld>
+    <p:spTree>
+      <p:nvGrpSpPr>
+        <p:cNvPr id="1" name="">
+          <a:extLst>
+            <a:ext uri="{FF2B5EF4-FFF2-40B4-BE49-F238E27FC236}">
+              <a16:creationId xmlns:a16="http://schemas.microsoft.com/office/drawing/2014/main" id="{D40DA93A-FC6D-A702-5D17-8D9209896285}"/>
+            </a:ext>
+          </a:extLst>
+        </p:cNvPr>
+        <p:cNvGrpSpPr/>
+        <p:nvPr/>
+      </p:nvGrpSpPr>
+      <p:grpSpPr>
+        <a:xfrm>
+          <a:off x="0" y="0"/>
+          <a:ext cx="0" cy="0"/>
+          <a:chOff x="0" y="0"/>
+          <a:chExt cx="0" cy="0"/>
+        </a:xfrm>
+      </p:grpSpPr>
+      <p:sp>
+        <p:nvSpPr>
+          <p:cNvPr id="2" name="Titel 1">
+            <a:extLst>
+              <a:ext uri="{FF2B5EF4-FFF2-40B4-BE49-F238E27FC236}">
+                <a16:creationId xmlns:a16="http://schemas.microsoft.com/office/drawing/2014/main" id="{491895BD-8E7B-4335-96EC-087F0343BD53}"/>
+              </a:ext>
+            </a:extLst>
+          </p:cNvPr>
+          <p:cNvSpPr>
+            <a:spLocks noGrp="1"/>
+          </p:cNvSpPr>
+          <p:nvPr>
+            <p:ph type="title"/>
+          </p:nvPr>
+        </p:nvSpPr>
+        <p:spPr/>
+        <p:txBody>
+          <a:bodyPr/>
+          <a:lstStyle/>
+          <a:p>
+            <a:r>
+              <a:rPr lang="de-DE" dirty="0" err="1"/>
+              <a:t>Comparison</a:t>
+            </a:r>
+            <a:r>
+              <a:rPr lang="de-DE" dirty="0"/>
+              <a:t> </a:t>
+            </a:r>
+            <a:r>
+              <a:rPr lang="de-DE" dirty="0" err="1"/>
+              <a:t>existing</a:t>
+            </a:r>
+            <a:r>
+              <a:rPr lang="de-DE" dirty="0"/>
+              <a:t> </a:t>
+            </a:r>
+            <a:r>
+              <a:rPr lang="de-DE" dirty="0" err="1"/>
+              <a:t>apps</a:t>
+            </a:r>
+            <a:endParaRPr lang="de-CH" dirty="0"/>
+          </a:p>
+        </p:txBody>
+      </p:sp>
+      <p:sp>
+        <p:nvSpPr>
+          <p:cNvPr id="3" name="Inhaltsplatzhalter 2">
+            <a:extLst>
+              <a:ext uri="{FF2B5EF4-FFF2-40B4-BE49-F238E27FC236}">
+                <a16:creationId xmlns:a16="http://schemas.microsoft.com/office/drawing/2014/main" id="{CEB45D22-943C-B119-970B-0241DE89AE5B}"/>
+              </a:ext>
+            </a:extLst>
+          </p:cNvPr>
+          <p:cNvSpPr>
+            <a:spLocks noGrp="1"/>
+          </p:cNvSpPr>
+          <p:nvPr>
+            <p:ph idx="1"/>
+          </p:nvPr>
+        </p:nvSpPr>
+        <p:spPr/>
+        <p:txBody>
+          <a:bodyPr/>
+          <a:lstStyle/>
+          <a:p>
+            <a:r>
+              <a:rPr lang="de-DE" dirty="0"/>
+              <a:t>Prozentual</a:t>
+            </a:r>
+            <a:endParaRPr lang="de-CH" dirty="0"/>
+          </a:p>
+          <a:p>
+            <a:endParaRPr lang="de-DE" dirty="0"/>
+          </a:p>
+          <a:p>
+            <a:endParaRPr lang="de-CH" dirty="0"/>
+          </a:p>
+        </p:txBody>
+      </p:sp>
+      <p:pic>
+        <p:nvPicPr>
+          <p:cNvPr id="6" name="Grafik 5" descr="Ein Bild, das Text, Screenshot, Diagramm, Schrift enthält.&#10;&#10;KI-generierte Inhalte können fehlerhaft sein.">
+            <a:extLst>
+              <a:ext uri="{FF2B5EF4-FFF2-40B4-BE49-F238E27FC236}">
+                <a16:creationId xmlns:a16="http://schemas.microsoft.com/office/drawing/2014/main" id="{45F74B60-C27A-F0AC-00EF-A00C348F720C}"/>
+              </a:ext>
+            </a:extLst>
+          </p:cNvPr>
+          <p:cNvPicPr>
+            <a:picLocks noChangeAspect="1"/>
+          </p:cNvPicPr>
+          <p:nvPr/>
+        </p:nvPicPr>
+        <p:blipFill>
+          <a:blip r:embed="rId2">
+            <a:extLst>
+              <a:ext uri="{28A0092B-C50C-407E-A947-70E740481C1C}">
+                <a14:useLocalDpi xmlns:a14="http://schemas.microsoft.com/office/drawing/2010/main" val="0"/>
+              </a:ext>
+            </a:extLst>
+          </a:blip>
+          <a:stretch>
+            <a:fillRect/>
+          </a:stretch>
+        </p:blipFill>
+        <p:spPr>
+          <a:xfrm>
+            <a:off x="4148313" y="1690688"/>
+            <a:ext cx="7205487" cy="4462281"/>
+          </a:xfrm>
+          <a:prstGeom prst="rect">
+            <a:avLst/>
+          </a:prstGeom>
+        </p:spPr>
+      </p:pic>
+    </p:spTree>
+    <p:extLst>
+      <p:ext uri="{BB962C8B-B14F-4D97-AF65-F5344CB8AC3E}">
+        <p14:creationId xmlns:p14="http://schemas.microsoft.com/office/powerpoint/2010/main" val="3436236071"/>
+      </p:ext>
+    </p:extLst>
+  </p:cSld>
+  <p:clrMapOvr>
+    <a:masterClrMapping/>
+  </p:clrMapOvr>
+</p:sld>
+</file>
+
+<file path=ppt/slides/slide17.xml><?xml version="1.0" encoding="utf-8"?>
+<p:sld xmlns:a="http://schemas.openxmlformats.org/drawingml/2006/main" xmlns:r="http://schemas.openxmlformats.org/officeDocument/2006/relationships" xmlns:p="http://schemas.openxmlformats.org/presentationml/2006/main">
+  <p:cSld>
+    <p:spTree>
+      <p:nvGrpSpPr>
+        <p:cNvPr id="1" name="">
+          <a:extLst>
+            <a:ext uri="{FF2B5EF4-FFF2-40B4-BE49-F238E27FC236}">
+              <a16:creationId xmlns:a16="http://schemas.microsoft.com/office/drawing/2014/main" id="{1CA542F7-776C-A15C-7975-6F99C9D5FAEC}"/>
+            </a:ext>
+          </a:extLst>
+        </p:cNvPr>
+        <p:cNvGrpSpPr/>
+        <p:nvPr/>
+      </p:nvGrpSpPr>
+      <p:grpSpPr>
+        <a:xfrm>
+          <a:off x="0" y="0"/>
+          <a:ext cx="0" cy="0"/>
+          <a:chOff x="0" y="0"/>
+          <a:chExt cx="0" cy="0"/>
+        </a:xfrm>
+      </p:grpSpPr>
+      <p:sp>
+        <p:nvSpPr>
+          <p:cNvPr id="2" name="Titel 1">
+            <a:extLst>
+              <a:ext uri="{FF2B5EF4-FFF2-40B4-BE49-F238E27FC236}">
+                <a16:creationId xmlns:a16="http://schemas.microsoft.com/office/drawing/2014/main" id="{710A0D67-C460-A50A-208B-EC51BC172345}"/>
+              </a:ext>
+            </a:extLst>
+          </p:cNvPr>
+          <p:cNvSpPr>
+            <a:spLocks noGrp="1"/>
+          </p:cNvSpPr>
+          <p:nvPr>
+            <p:ph type="title"/>
+          </p:nvPr>
+        </p:nvSpPr>
+        <p:spPr/>
+        <p:txBody>
+          <a:bodyPr/>
+          <a:lstStyle/>
+          <a:p>
+            <a:r>
+              <a:rPr lang="de-DE" dirty="0" err="1"/>
+              <a:t>Comparison</a:t>
+            </a:r>
+            <a:r>
+              <a:rPr lang="de-DE" dirty="0"/>
+              <a:t> </a:t>
+            </a:r>
+            <a:r>
+              <a:rPr lang="de-DE" dirty="0" err="1"/>
+              <a:t>existing</a:t>
+            </a:r>
+            <a:r>
+              <a:rPr lang="de-DE" dirty="0"/>
+              <a:t> </a:t>
+            </a:r>
+            <a:r>
+              <a:rPr lang="de-DE" dirty="0" err="1"/>
+              <a:t>apps</a:t>
+            </a:r>
+            <a:endParaRPr lang="de-CH" dirty="0"/>
+          </a:p>
+        </p:txBody>
+      </p:sp>
+      <p:sp>
+        <p:nvSpPr>
+          <p:cNvPr id="3" name="Inhaltsplatzhalter 2">
+            <a:extLst>
+              <a:ext uri="{FF2B5EF4-FFF2-40B4-BE49-F238E27FC236}">
+                <a16:creationId xmlns:a16="http://schemas.microsoft.com/office/drawing/2014/main" id="{90935BDE-4551-097A-CC0D-80F03400D60B}"/>
+              </a:ext>
+            </a:extLst>
+          </p:cNvPr>
+          <p:cNvSpPr>
+            <a:spLocks noGrp="1"/>
+          </p:cNvSpPr>
+          <p:nvPr>
+            <p:ph idx="1"/>
+          </p:nvPr>
+        </p:nvSpPr>
+        <p:spPr/>
+        <p:txBody>
+          <a:bodyPr/>
+          <a:lstStyle/>
+          <a:p>
+            <a:r>
+              <a:rPr lang="de-DE" dirty="0"/>
+              <a:t>Total</a:t>
+            </a:r>
+            <a:endParaRPr lang="de-CH" dirty="0"/>
+          </a:p>
+          <a:p>
+            <a:endParaRPr lang="de-DE" dirty="0"/>
+          </a:p>
+          <a:p>
+            <a:endParaRPr lang="de-CH" dirty="0"/>
+          </a:p>
+        </p:txBody>
+      </p:sp>
+      <p:pic>
+        <p:nvPicPr>
+          <p:cNvPr id="6" name="Grafik 5" descr="Ein Bild, das Text, Screenshot, Diagramm, Reihe enthält.&#10;&#10;KI-generierte Inhalte können fehlerhaft sein.">
+            <a:extLst>
+              <a:ext uri="{FF2B5EF4-FFF2-40B4-BE49-F238E27FC236}">
+                <a16:creationId xmlns:a16="http://schemas.microsoft.com/office/drawing/2014/main" id="{00A0078B-8B76-103D-1E9D-0E1190734E04}"/>
+              </a:ext>
+            </a:extLst>
+          </p:cNvPr>
+          <p:cNvPicPr>
+            <a:picLocks noChangeAspect="1"/>
+          </p:cNvPicPr>
+          <p:nvPr/>
+        </p:nvPicPr>
+        <p:blipFill>
+          <a:blip r:embed="rId2">
+            <a:extLst>
+              <a:ext uri="{28A0092B-C50C-407E-A947-70E740481C1C}">
+                <a14:useLocalDpi xmlns:a14="http://schemas.microsoft.com/office/drawing/2010/main" val="0"/>
+              </a:ext>
+            </a:extLst>
+          </a:blip>
+          <a:stretch>
+            <a:fillRect/>
+          </a:stretch>
+        </p:blipFill>
+        <p:spPr>
+          <a:xfrm>
+            <a:off x="3233911" y="1690688"/>
+            <a:ext cx="8119889" cy="4419609"/>
+          </a:xfrm>
+          <a:prstGeom prst="rect">
+            <a:avLst/>
+          </a:prstGeom>
+        </p:spPr>
+      </p:pic>
+    </p:spTree>
+    <p:extLst>
+      <p:ext uri="{BB962C8B-B14F-4D97-AF65-F5344CB8AC3E}">
+        <p14:creationId xmlns:p14="http://schemas.microsoft.com/office/powerpoint/2010/main" val="3264775351"/>
+      </p:ext>
+    </p:extLst>
+  </p:cSld>
+  <p:clrMapOvr>
+    <a:masterClrMapping/>
+  </p:clrMapOvr>
+</p:sld>
+</file>
+
+<file path=ppt/slides/slide18.xml><?xml version="1.0" encoding="utf-8"?>
+<p:sld xmlns:a="http://schemas.openxmlformats.org/drawingml/2006/main" xmlns:r="http://schemas.openxmlformats.org/officeDocument/2006/relationships" xmlns:p="http://schemas.openxmlformats.org/presentationml/2006/main">
+  <p:cSld>
+    <p:spTree>
+      <p:nvGrpSpPr>
+        <p:cNvPr id="1" name="">
+          <a:extLst>
+            <a:ext uri="{FF2B5EF4-FFF2-40B4-BE49-F238E27FC236}">
+              <a16:creationId xmlns:a16="http://schemas.microsoft.com/office/drawing/2014/main" id="{86AB97CC-0D7E-CA14-54AD-DD1B10334272}"/>
+            </a:ext>
+          </a:extLst>
+        </p:cNvPr>
+        <p:cNvGrpSpPr/>
+        <p:nvPr/>
+      </p:nvGrpSpPr>
+      <p:grpSpPr>
+        <a:xfrm>
+          <a:off x="0" y="0"/>
+          <a:ext cx="0" cy="0"/>
+          <a:chOff x="0" y="0"/>
+          <a:chExt cx="0" cy="0"/>
+        </a:xfrm>
+      </p:grpSpPr>
+      <p:sp>
+        <p:nvSpPr>
+          <p:cNvPr id="2" name="Titel 1">
+            <a:extLst>
+              <a:ext uri="{FF2B5EF4-FFF2-40B4-BE49-F238E27FC236}">
+                <a16:creationId xmlns:a16="http://schemas.microsoft.com/office/drawing/2014/main" id="{97E97291-21D4-693D-3115-FB898285C157}"/>
+              </a:ext>
+            </a:extLst>
+          </p:cNvPr>
+          <p:cNvSpPr>
+            <a:spLocks noGrp="1"/>
+          </p:cNvSpPr>
+          <p:nvPr>
+            <p:ph type="title"/>
+          </p:nvPr>
+        </p:nvSpPr>
+        <p:spPr/>
+        <p:txBody>
+          <a:bodyPr/>
+          <a:lstStyle/>
+          <a:p>
+            <a:r>
+              <a:rPr lang="de-DE" dirty="0" err="1"/>
+              <a:t>Comparison</a:t>
+            </a:r>
+            <a:r>
+              <a:rPr lang="de-DE" dirty="0"/>
+              <a:t> </a:t>
+            </a:r>
+            <a:r>
+              <a:rPr lang="de-DE" dirty="0" err="1"/>
+              <a:t>existing</a:t>
+            </a:r>
+            <a:r>
+              <a:rPr lang="de-DE" dirty="0"/>
+              <a:t> </a:t>
+            </a:r>
+            <a:r>
+              <a:rPr lang="de-DE" dirty="0" err="1"/>
+              <a:t>apps</a:t>
+            </a:r>
+            <a:endParaRPr lang="de-CH" dirty="0"/>
+          </a:p>
+        </p:txBody>
+      </p:sp>
+      <p:sp>
+        <p:nvSpPr>
+          <p:cNvPr id="3" name="Inhaltsplatzhalter 2">
+            <a:extLst>
+              <a:ext uri="{FF2B5EF4-FFF2-40B4-BE49-F238E27FC236}">
+                <a16:creationId xmlns:a16="http://schemas.microsoft.com/office/drawing/2014/main" id="{80840164-2A75-53FE-A2BD-7D98A0DC69A4}"/>
+              </a:ext>
+            </a:extLst>
+          </p:cNvPr>
+          <p:cNvSpPr>
+            <a:spLocks noGrp="1"/>
+          </p:cNvSpPr>
+          <p:nvPr>
+            <p:ph idx="1"/>
+          </p:nvPr>
+        </p:nvSpPr>
+        <p:spPr/>
+        <p:txBody>
+          <a:bodyPr/>
+          <a:lstStyle/>
+          <a:p>
+            <a:r>
+              <a:rPr lang="de-DE" dirty="0"/>
+              <a:t>Total</a:t>
+            </a:r>
+            <a:endParaRPr lang="de-CH" dirty="0"/>
+          </a:p>
+          <a:p>
+            <a:endParaRPr lang="de-DE" dirty="0"/>
+          </a:p>
+          <a:p>
+            <a:endParaRPr lang="de-CH" dirty="0"/>
+          </a:p>
+        </p:txBody>
+      </p:sp>
+      <p:pic>
+        <p:nvPicPr>
+          <p:cNvPr id="5" name="Grafik 4" descr="Ein Bild, das Text, Screenshot, Diagramm, Reihe enthält.&#10;&#10;KI-generierte Inhalte können fehlerhaft sein.">
+            <a:extLst>
+              <a:ext uri="{FF2B5EF4-FFF2-40B4-BE49-F238E27FC236}">
+                <a16:creationId xmlns:a16="http://schemas.microsoft.com/office/drawing/2014/main" id="{E0252EF5-E639-CEBB-DECE-9E6330F584BD}"/>
+              </a:ext>
+            </a:extLst>
+          </p:cNvPr>
+          <p:cNvPicPr>
+            <a:picLocks noChangeAspect="1"/>
+          </p:cNvPicPr>
+          <p:nvPr/>
+        </p:nvPicPr>
+        <p:blipFill>
+          <a:blip r:embed="rId2">
+            <a:extLst>
+              <a:ext uri="{28A0092B-C50C-407E-A947-70E740481C1C}">
+                <a14:useLocalDpi xmlns:a14="http://schemas.microsoft.com/office/drawing/2010/main" val="0"/>
+              </a:ext>
+            </a:extLst>
+          </a:blip>
+          <a:stretch>
+            <a:fillRect/>
+          </a:stretch>
+        </p:blipFill>
+        <p:spPr>
+          <a:xfrm>
+            <a:off x="3233911" y="1690688"/>
+            <a:ext cx="8119889" cy="4419609"/>
+          </a:xfrm>
+          <a:prstGeom prst="rect">
+            <a:avLst/>
+          </a:prstGeom>
+        </p:spPr>
+      </p:pic>
+    </p:spTree>
+    <p:extLst>
+      <p:ext uri="{BB962C8B-B14F-4D97-AF65-F5344CB8AC3E}">
+        <p14:creationId xmlns:p14="http://schemas.microsoft.com/office/powerpoint/2010/main" val="2232898064"/>
+      </p:ext>
+    </p:extLst>
+  </p:cSld>
+  <p:clrMapOvr>
+    <a:masterClrMapping/>
+  </p:clrMapOvr>
+</p:sld>
+</file>
+
+<file path=ppt/slides/slide19.xml><?xml version="1.0" encoding="utf-8"?>
+<p:sld xmlns:a="http://schemas.openxmlformats.org/drawingml/2006/main" xmlns:r="http://schemas.openxmlformats.org/officeDocument/2006/relationships" xmlns:p="http://schemas.openxmlformats.org/presentationml/2006/main">
+  <p:cSld>
+    <p:spTree>
+      <p:nvGrpSpPr>
+        <p:cNvPr id="1" name="">
+          <a:extLst>
+            <a:ext uri="{FF2B5EF4-FFF2-40B4-BE49-F238E27FC236}">
+              <a16:creationId xmlns:a16="http://schemas.microsoft.com/office/drawing/2014/main" id="{4B3E2659-B5EB-0A14-421F-65F275DE3133}"/>
+            </a:ext>
+          </a:extLst>
+        </p:cNvPr>
+        <p:cNvGrpSpPr/>
+        <p:nvPr/>
+      </p:nvGrpSpPr>
+      <p:grpSpPr>
+        <a:xfrm>
+          <a:off x="0" y="0"/>
+          <a:ext cx="0" cy="0"/>
+          <a:chOff x="0" y="0"/>
+          <a:chExt cx="0" cy="0"/>
+        </a:xfrm>
+      </p:grpSpPr>
+      <p:sp>
+        <p:nvSpPr>
+          <p:cNvPr id="2" name="Titel 1">
+            <a:extLst>
+              <a:ext uri="{FF2B5EF4-FFF2-40B4-BE49-F238E27FC236}">
+                <a16:creationId xmlns:a16="http://schemas.microsoft.com/office/drawing/2014/main" id="{E909BA74-FB10-7E7B-248A-DB7459B4CECB}"/>
+              </a:ext>
+            </a:extLst>
+          </p:cNvPr>
+          <p:cNvSpPr>
+            <a:spLocks noGrp="1"/>
+          </p:cNvSpPr>
+          <p:nvPr>
+            <p:ph type="title"/>
+          </p:nvPr>
+        </p:nvSpPr>
+        <p:spPr/>
+        <p:txBody>
+          <a:bodyPr/>
+          <a:lstStyle/>
+          <a:p>
+            <a:r>
+              <a:rPr lang="de-DE" dirty="0" err="1"/>
+              <a:t>Comparison</a:t>
+            </a:r>
+            <a:r>
+              <a:rPr lang="de-DE" dirty="0"/>
+              <a:t> </a:t>
+            </a:r>
+            <a:r>
+              <a:rPr lang="de-DE" dirty="0" err="1"/>
+              <a:t>existing</a:t>
+            </a:r>
+            <a:r>
+              <a:rPr lang="de-DE" dirty="0"/>
+              <a:t> </a:t>
+            </a:r>
+            <a:r>
+              <a:rPr lang="de-DE" dirty="0" err="1"/>
+              <a:t>apps</a:t>
+            </a:r>
+            <a:endParaRPr lang="de-CH" dirty="0"/>
+          </a:p>
+        </p:txBody>
+      </p:sp>
+      <p:sp>
+        <p:nvSpPr>
+          <p:cNvPr id="3" name="Inhaltsplatzhalter 2">
+            <a:extLst>
+              <a:ext uri="{FF2B5EF4-FFF2-40B4-BE49-F238E27FC236}">
+                <a16:creationId xmlns:a16="http://schemas.microsoft.com/office/drawing/2014/main" id="{BE8F70F3-A3C9-B585-5CD7-CD0724A7ACE9}"/>
+              </a:ext>
+            </a:extLst>
+          </p:cNvPr>
+          <p:cNvSpPr>
+            <a:spLocks noGrp="1"/>
+          </p:cNvSpPr>
+          <p:nvPr>
+            <p:ph idx="1"/>
+          </p:nvPr>
+        </p:nvSpPr>
+        <p:spPr/>
+        <p:txBody>
+          <a:bodyPr/>
+          <a:lstStyle/>
+          <a:p>
+            <a:r>
+              <a:rPr lang="de-DE" dirty="0"/>
+              <a:t>„Neuheit“ der </a:t>
+            </a:r>
+            <a:r>
+              <a:rPr lang="de-DE" dirty="0" err="1"/>
+              <a:t>Vulnerabilities</a:t>
+            </a:r>
+            <a:endParaRPr lang="de-CH" dirty="0"/>
+          </a:p>
+          <a:p>
+            <a:endParaRPr lang="de-DE" dirty="0"/>
+          </a:p>
+          <a:p>
+            <a:endParaRPr lang="de-CH" dirty="0"/>
+          </a:p>
+        </p:txBody>
+      </p:sp>
+      <p:pic>
+        <p:nvPicPr>
+          <p:cNvPr id="6" name="Grafik 5" descr="Ein Bild, das Text, Screenshot, Diagramm, Schrift enthält.&#10;&#10;KI-generierte Inhalte können fehlerhaft sein.">
+            <a:extLst>
+              <a:ext uri="{FF2B5EF4-FFF2-40B4-BE49-F238E27FC236}">
+                <a16:creationId xmlns:a16="http://schemas.microsoft.com/office/drawing/2014/main" id="{537129AF-0B8F-0056-DFF0-450380064D09}"/>
+              </a:ext>
+            </a:extLst>
+          </p:cNvPr>
+          <p:cNvPicPr>
+            <a:picLocks noChangeAspect="1"/>
+          </p:cNvPicPr>
+          <p:nvPr/>
+        </p:nvPicPr>
+        <p:blipFill>
+          <a:blip r:embed="rId2">
+            <a:extLst>
+              <a:ext uri="{28A0092B-C50C-407E-A947-70E740481C1C}">
+                <a14:useLocalDpi xmlns:a14="http://schemas.microsoft.com/office/drawing/2010/main" val="0"/>
+              </a:ext>
+            </a:extLst>
+          </a:blip>
+          <a:stretch>
+            <a:fillRect/>
+          </a:stretch>
+        </p:blipFill>
+        <p:spPr>
+          <a:xfrm>
+            <a:off x="4822370" y="2417974"/>
+            <a:ext cx="6862383" cy="4074901"/>
+          </a:xfrm>
+          <a:prstGeom prst="rect">
+            <a:avLst/>
+          </a:prstGeom>
+        </p:spPr>
+      </p:pic>
+    </p:spTree>
+    <p:extLst>
+      <p:ext uri="{BB962C8B-B14F-4D97-AF65-F5344CB8AC3E}">
+        <p14:creationId xmlns:p14="http://schemas.microsoft.com/office/powerpoint/2010/main" val="4270006515"/>
+      </p:ext>
+    </p:extLst>
+  </p:cSld>
+  <p:clrMapOvr>
+    <a:masterClrMapping/>
+  </p:clrMapOvr>
+</p:sld>
+</file>
+
 <file path=ppt/slides/slide2.xml><?xml version="1.0" encoding="utf-8"?>
 <p:sld xmlns:a="http://schemas.openxmlformats.org/drawingml/2006/main" xmlns:r="http://schemas.openxmlformats.org/officeDocument/2006/relationships" xmlns:p="http://schemas.openxmlformats.org/presentationml/2006/main">
   <p:cSld>
@@ -3535,6 +5561,511 @@
     <p:extLst>
       <p:ext uri="{BB962C8B-B14F-4D97-AF65-F5344CB8AC3E}">
         <p14:creationId xmlns:p14="http://schemas.microsoft.com/office/powerpoint/2010/main" val="4120726205"/>
+      </p:ext>
+    </p:extLst>
+  </p:cSld>
+  <p:clrMapOvr>
+    <a:masterClrMapping/>
+  </p:clrMapOvr>
+</p:sld>
+</file>
+
+<file path=ppt/slides/slide20.xml><?xml version="1.0" encoding="utf-8"?>
+<p:sld xmlns:a="http://schemas.openxmlformats.org/drawingml/2006/main" xmlns:r="http://schemas.openxmlformats.org/officeDocument/2006/relationships" xmlns:p="http://schemas.openxmlformats.org/presentationml/2006/main">
+  <p:cSld>
+    <p:spTree>
+      <p:nvGrpSpPr>
+        <p:cNvPr id="1" name="">
+          <a:extLst>
+            <a:ext uri="{FF2B5EF4-FFF2-40B4-BE49-F238E27FC236}">
+              <a16:creationId xmlns:a16="http://schemas.microsoft.com/office/drawing/2014/main" id="{8941DC2E-FE8C-E873-4563-9A9728450523}"/>
+            </a:ext>
+          </a:extLst>
+        </p:cNvPr>
+        <p:cNvGrpSpPr/>
+        <p:nvPr/>
+      </p:nvGrpSpPr>
+      <p:grpSpPr>
+        <a:xfrm>
+          <a:off x="0" y="0"/>
+          <a:ext cx="0" cy="0"/>
+          <a:chOff x="0" y="0"/>
+          <a:chExt cx="0" cy="0"/>
+        </a:xfrm>
+      </p:grpSpPr>
+      <p:sp>
+        <p:nvSpPr>
+          <p:cNvPr id="2" name="Titel 1">
+            <a:extLst>
+              <a:ext uri="{FF2B5EF4-FFF2-40B4-BE49-F238E27FC236}">
+                <a16:creationId xmlns:a16="http://schemas.microsoft.com/office/drawing/2014/main" id="{0AACE4DA-34F2-227F-B7E7-698E9E5865AB}"/>
+              </a:ext>
+            </a:extLst>
+          </p:cNvPr>
+          <p:cNvSpPr>
+            <a:spLocks noGrp="1"/>
+          </p:cNvSpPr>
+          <p:nvPr>
+            <p:ph type="title"/>
+          </p:nvPr>
+        </p:nvSpPr>
+        <p:spPr/>
+        <p:txBody>
+          <a:bodyPr/>
+          <a:lstStyle/>
+          <a:p>
+            <a:r>
+              <a:rPr lang="de-DE" dirty="0" err="1"/>
+              <a:t>Comparison</a:t>
+            </a:r>
+            <a:r>
+              <a:rPr lang="de-DE" dirty="0"/>
+              <a:t> </a:t>
+            </a:r>
+            <a:r>
+              <a:rPr lang="de-DE" dirty="0" err="1"/>
+              <a:t>existing</a:t>
+            </a:r>
+            <a:r>
+              <a:rPr lang="de-DE" dirty="0"/>
+              <a:t> </a:t>
+            </a:r>
+            <a:r>
+              <a:rPr lang="de-DE" dirty="0" err="1"/>
+              <a:t>apps</a:t>
+            </a:r>
+            <a:endParaRPr lang="de-CH" dirty="0"/>
+          </a:p>
+        </p:txBody>
+      </p:sp>
+      <p:sp>
+        <p:nvSpPr>
+          <p:cNvPr id="3" name="Inhaltsplatzhalter 2">
+            <a:extLst>
+              <a:ext uri="{FF2B5EF4-FFF2-40B4-BE49-F238E27FC236}">
+                <a16:creationId xmlns:a16="http://schemas.microsoft.com/office/drawing/2014/main" id="{089E0A9C-9F47-A5E9-7F21-87FF243BB60F}"/>
+              </a:ext>
+            </a:extLst>
+          </p:cNvPr>
+          <p:cNvSpPr>
+            <a:spLocks noGrp="1"/>
+          </p:cNvSpPr>
+          <p:nvPr>
+            <p:ph idx="1"/>
+          </p:nvPr>
+        </p:nvSpPr>
+        <p:spPr/>
+        <p:txBody>
+          <a:bodyPr/>
+          <a:lstStyle/>
+          <a:p>
+            <a:r>
+              <a:rPr lang="de-DE" dirty="0"/>
+              <a:t>„Neuheit“ der </a:t>
+            </a:r>
+            <a:r>
+              <a:rPr lang="de-DE" dirty="0" err="1"/>
+              <a:t>Vulnerabilities</a:t>
+            </a:r>
+            <a:endParaRPr lang="de-DE" dirty="0"/>
+          </a:p>
+          <a:p>
+            <a:r>
+              <a:rPr lang="de-DE" dirty="0"/>
+              <a:t>38 </a:t>
+            </a:r>
+            <a:r>
+              <a:rPr lang="de-DE" dirty="0" err="1"/>
+              <a:t>unique</a:t>
+            </a:r>
+            <a:r>
+              <a:rPr lang="de-DE" dirty="0"/>
+              <a:t> ohne BA</a:t>
+            </a:r>
+          </a:p>
+          <a:p>
+            <a:r>
+              <a:rPr lang="de-DE" dirty="0"/>
+              <a:t>58 </a:t>
+            </a:r>
+            <a:r>
+              <a:rPr lang="de-DE" dirty="0" err="1"/>
+              <a:t>unique</a:t>
+            </a:r>
+            <a:r>
+              <a:rPr lang="de-DE" dirty="0"/>
+              <a:t> mit BA</a:t>
+            </a:r>
+          </a:p>
+          <a:p>
+            <a:r>
+              <a:rPr lang="de-DE" dirty="0"/>
+              <a:t>20/28 gab es noch nicht</a:t>
+            </a:r>
+          </a:p>
+          <a:p>
+            <a:endParaRPr lang="de-CH" dirty="0"/>
+          </a:p>
+          <a:p>
+            <a:endParaRPr lang="de-DE" dirty="0"/>
+          </a:p>
+          <a:p>
+            <a:endParaRPr lang="de-CH" dirty="0"/>
+          </a:p>
+        </p:txBody>
+      </p:sp>
+      <p:pic>
+        <p:nvPicPr>
+          <p:cNvPr id="5" name="Grafik 4" descr="Ein Bild, das Text, Diagramm, Screenshot, Reihe enthält.&#10;&#10;KI-generierte Inhalte können fehlerhaft sein.">
+            <a:extLst>
+              <a:ext uri="{FF2B5EF4-FFF2-40B4-BE49-F238E27FC236}">
+                <a16:creationId xmlns:a16="http://schemas.microsoft.com/office/drawing/2014/main" id="{4E30C47E-C2B9-91F0-CC9D-7EB3569BE352}"/>
+              </a:ext>
+            </a:extLst>
+          </p:cNvPr>
+          <p:cNvPicPr>
+            <a:picLocks noChangeAspect="1"/>
+          </p:cNvPicPr>
+          <p:nvPr/>
+        </p:nvPicPr>
+        <p:blipFill>
+          <a:blip r:embed="rId2">
+            <a:extLst>
+              <a:ext uri="{28A0092B-C50C-407E-A947-70E740481C1C}">
+                <a14:useLocalDpi xmlns:a14="http://schemas.microsoft.com/office/drawing/2010/main" val="0"/>
+              </a:ext>
+            </a:extLst>
+          </a:blip>
+          <a:stretch>
+            <a:fillRect/>
+          </a:stretch>
+        </p:blipFill>
+        <p:spPr>
+          <a:xfrm>
+            <a:off x="5269607" y="2475014"/>
+            <a:ext cx="6463727" cy="3836886"/>
+          </a:xfrm>
+          <a:prstGeom prst="rect">
+            <a:avLst/>
+          </a:prstGeom>
+        </p:spPr>
+      </p:pic>
+    </p:spTree>
+    <p:extLst>
+      <p:ext uri="{BB962C8B-B14F-4D97-AF65-F5344CB8AC3E}">
+        <p14:creationId xmlns:p14="http://schemas.microsoft.com/office/powerpoint/2010/main" val="3832337785"/>
+      </p:ext>
+    </p:extLst>
+  </p:cSld>
+  <p:clrMapOvr>
+    <a:masterClrMapping/>
+  </p:clrMapOvr>
+</p:sld>
+</file>
+
+<file path=ppt/slides/slide21.xml><?xml version="1.0" encoding="utf-8"?>
+<p:sld xmlns:a="http://schemas.openxmlformats.org/drawingml/2006/main" xmlns:r="http://schemas.openxmlformats.org/officeDocument/2006/relationships" xmlns:p="http://schemas.openxmlformats.org/presentationml/2006/main">
+  <p:cSld>
+    <p:spTree>
+      <p:nvGrpSpPr>
+        <p:cNvPr id="1" name="">
+          <a:extLst>
+            <a:ext uri="{FF2B5EF4-FFF2-40B4-BE49-F238E27FC236}">
+              <a16:creationId xmlns:a16="http://schemas.microsoft.com/office/drawing/2014/main" id="{612A5375-1879-9958-647A-C08A34B668CA}"/>
+            </a:ext>
+          </a:extLst>
+        </p:cNvPr>
+        <p:cNvGrpSpPr/>
+        <p:nvPr/>
+      </p:nvGrpSpPr>
+      <p:grpSpPr>
+        <a:xfrm>
+          <a:off x="0" y="0"/>
+          <a:ext cx="0" cy="0"/>
+          <a:chOff x="0" y="0"/>
+          <a:chExt cx="0" cy="0"/>
+        </a:xfrm>
+      </p:grpSpPr>
+      <p:sp>
+        <p:nvSpPr>
+          <p:cNvPr id="2" name="Titel 1">
+            <a:extLst>
+              <a:ext uri="{FF2B5EF4-FFF2-40B4-BE49-F238E27FC236}">
+                <a16:creationId xmlns:a16="http://schemas.microsoft.com/office/drawing/2014/main" id="{2CA23DAA-217C-43FE-E8A0-8DCDAB7DFDE6}"/>
+              </a:ext>
+            </a:extLst>
+          </p:cNvPr>
+          <p:cNvSpPr>
+            <a:spLocks noGrp="1"/>
+          </p:cNvSpPr>
+          <p:nvPr>
+            <p:ph type="title"/>
+          </p:nvPr>
+        </p:nvSpPr>
+        <p:spPr/>
+        <p:txBody>
+          <a:bodyPr/>
+          <a:lstStyle/>
+          <a:p>
+            <a:r>
+              <a:rPr lang="de-DE" dirty="0" err="1"/>
+              <a:t>Comparison</a:t>
+            </a:r>
+            <a:r>
+              <a:rPr lang="de-DE" dirty="0"/>
+              <a:t> </a:t>
+            </a:r>
+            <a:r>
+              <a:rPr lang="de-DE" dirty="0" err="1"/>
+              <a:t>existing</a:t>
+            </a:r>
+            <a:r>
+              <a:rPr lang="de-DE" dirty="0"/>
+              <a:t> </a:t>
+            </a:r>
+            <a:r>
+              <a:rPr lang="de-DE" dirty="0" err="1"/>
+              <a:t>apps</a:t>
+            </a:r>
+            <a:endParaRPr lang="de-CH" dirty="0"/>
+          </a:p>
+        </p:txBody>
+      </p:sp>
+      <p:pic>
+        <p:nvPicPr>
+          <p:cNvPr id="6" name="Grafik 5" descr="Ein Bild, das Text, Screenshot, Diagramm, Reihe enthält.&#10;&#10;KI-generierte Inhalte können fehlerhaft sein.">
+            <a:extLst>
+              <a:ext uri="{FF2B5EF4-FFF2-40B4-BE49-F238E27FC236}">
+                <a16:creationId xmlns:a16="http://schemas.microsoft.com/office/drawing/2014/main" id="{891F4C76-28FF-1D5A-110F-9B74BC56779B}"/>
+              </a:ext>
+            </a:extLst>
+          </p:cNvPr>
+          <p:cNvPicPr>
+            <a:picLocks noChangeAspect="1"/>
+          </p:cNvPicPr>
+          <p:nvPr/>
+        </p:nvPicPr>
+        <p:blipFill>
+          <a:blip r:embed="rId2">
+            <a:extLst>
+              <a:ext uri="{28A0092B-C50C-407E-A947-70E740481C1C}">
+                <a14:useLocalDpi xmlns:a14="http://schemas.microsoft.com/office/drawing/2010/main" val="0"/>
+              </a:ext>
+            </a:extLst>
+          </a:blip>
+          <a:stretch>
+            <a:fillRect/>
+          </a:stretch>
+        </p:blipFill>
+        <p:spPr>
+          <a:xfrm>
+            <a:off x="414081" y="1459333"/>
+            <a:ext cx="10863094" cy="5245619"/>
+          </a:xfrm>
+          <a:prstGeom prst="rect">
+            <a:avLst/>
+          </a:prstGeom>
+        </p:spPr>
+      </p:pic>
+    </p:spTree>
+    <p:extLst>
+      <p:ext uri="{BB962C8B-B14F-4D97-AF65-F5344CB8AC3E}">
+        <p14:creationId xmlns:p14="http://schemas.microsoft.com/office/powerpoint/2010/main" val="960193812"/>
+      </p:ext>
+    </p:extLst>
+  </p:cSld>
+  <p:clrMapOvr>
+    <a:masterClrMapping/>
+  </p:clrMapOvr>
+</p:sld>
+</file>
+
+<file path=ppt/slides/slide22.xml><?xml version="1.0" encoding="utf-8"?>
+<p:sld xmlns:a="http://schemas.openxmlformats.org/drawingml/2006/main" xmlns:r="http://schemas.openxmlformats.org/officeDocument/2006/relationships" xmlns:p="http://schemas.openxmlformats.org/presentationml/2006/main">
+  <p:cSld>
+    <p:spTree>
+      <p:nvGrpSpPr>
+        <p:cNvPr id="1" name="">
+          <a:extLst>
+            <a:ext uri="{FF2B5EF4-FFF2-40B4-BE49-F238E27FC236}">
+              <a16:creationId xmlns:a16="http://schemas.microsoft.com/office/drawing/2014/main" id="{B9614D09-ADE7-5DA4-59E5-20A240212296}"/>
+            </a:ext>
+          </a:extLst>
+        </p:cNvPr>
+        <p:cNvGrpSpPr/>
+        <p:nvPr/>
+      </p:nvGrpSpPr>
+      <p:grpSpPr>
+        <a:xfrm>
+          <a:off x="0" y="0"/>
+          <a:ext cx="0" cy="0"/>
+          <a:chOff x="0" y="0"/>
+          <a:chExt cx="0" cy="0"/>
+        </a:xfrm>
+      </p:grpSpPr>
+      <p:sp>
+        <p:nvSpPr>
+          <p:cNvPr id="2" name="Titel 1">
+            <a:extLst>
+              <a:ext uri="{FF2B5EF4-FFF2-40B4-BE49-F238E27FC236}">
+                <a16:creationId xmlns:a16="http://schemas.microsoft.com/office/drawing/2014/main" id="{C91DAF64-7F93-2ED8-0693-63B19EFCBB3B}"/>
+              </a:ext>
+            </a:extLst>
+          </p:cNvPr>
+          <p:cNvSpPr>
+            <a:spLocks noGrp="1"/>
+          </p:cNvSpPr>
+          <p:nvPr>
+            <p:ph type="title"/>
+          </p:nvPr>
+        </p:nvSpPr>
+        <p:spPr/>
+        <p:txBody>
+          <a:bodyPr/>
+          <a:lstStyle/>
+          <a:p>
+            <a:r>
+              <a:rPr lang="de-DE" dirty="0"/>
+              <a:t>Nächste Schritte</a:t>
+            </a:r>
+            <a:endParaRPr lang="de-CH" dirty="0"/>
+          </a:p>
+        </p:txBody>
+      </p:sp>
+      <p:sp>
+        <p:nvSpPr>
+          <p:cNvPr id="3" name="Inhaltsplatzhalter 2">
+            <a:extLst>
+              <a:ext uri="{FF2B5EF4-FFF2-40B4-BE49-F238E27FC236}">
+                <a16:creationId xmlns:a16="http://schemas.microsoft.com/office/drawing/2014/main" id="{DF953D79-02F3-AFDE-DF34-2C70550FD508}"/>
+              </a:ext>
+            </a:extLst>
+          </p:cNvPr>
+          <p:cNvSpPr>
+            <a:spLocks noGrp="1"/>
+          </p:cNvSpPr>
+          <p:nvPr>
+            <p:ph idx="1"/>
+          </p:nvPr>
+        </p:nvSpPr>
+        <p:spPr>
+          <a:xfrm>
+            <a:off x="838200" y="1825625"/>
+            <a:ext cx="10515600" cy="4351338"/>
+          </a:xfrm>
+        </p:spPr>
+        <p:txBody>
+          <a:bodyPr/>
+          <a:lstStyle/>
+          <a:p>
+            <a:pPr marL="0" indent="0">
+              <a:buNone/>
+            </a:pPr>
+            <a:r>
+              <a:rPr lang="de-DE" dirty="0"/>
+              <a:t>BA </a:t>
+            </a:r>
+            <a:r>
+              <a:rPr lang="de-DE" dirty="0">
+                <a:sym typeface="Wingdings" panose="05000000000000000000" pitchFamily="2" charset="2"/>
+              </a:rPr>
+              <a:t></a:t>
+            </a:r>
+          </a:p>
+          <a:p>
+            <a:r>
+              <a:rPr lang="de-DE" dirty="0">
+                <a:sym typeface="Wingdings" panose="05000000000000000000" pitchFamily="2" charset="2"/>
+              </a:rPr>
+              <a:t>Intro, </a:t>
+            </a:r>
+            <a:r>
+              <a:rPr lang="de-DE" dirty="0" err="1">
+                <a:sym typeface="Wingdings" panose="05000000000000000000" pitchFamily="2" charset="2"/>
+              </a:rPr>
+              <a:t>background</a:t>
+            </a:r>
+            <a:r>
+              <a:rPr lang="de-DE" dirty="0">
+                <a:sym typeface="Wingdings" panose="05000000000000000000" pitchFamily="2" charset="2"/>
+              </a:rPr>
+              <a:t> &amp; </a:t>
+            </a:r>
+            <a:r>
+              <a:rPr lang="de-DE" dirty="0" err="1">
+                <a:sym typeface="Wingdings" panose="05000000000000000000" pitchFamily="2" charset="2"/>
+              </a:rPr>
+              <a:t>discussion</a:t>
+            </a:r>
+            <a:r>
+              <a:rPr lang="de-DE" dirty="0">
+                <a:sym typeface="Wingdings" panose="05000000000000000000" pitchFamily="2" charset="2"/>
+              </a:rPr>
+              <a:t> -&gt; „rein Text“</a:t>
+            </a:r>
+          </a:p>
+          <a:p>
+            <a:r>
+              <a:rPr lang="de-DE" dirty="0">
+                <a:sym typeface="Wingdings" panose="05000000000000000000" pitchFamily="2" charset="2"/>
+              </a:rPr>
+              <a:t>Design, Implementation  &amp; </a:t>
+            </a:r>
+            <a:r>
+              <a:rPr lang="de-DE" dirty="0" err="1">
+                <a:sym typeface="Wingdings" panose="05000000000000000000" pitchFamily="2" charset="2"/>
+              </a:rPr>
+              <a:t>Results</a:t>
+            </a:r>
+            <a:r>
+              <a:rPr lang="de-DE" dirty="0">
+                <a:sym typeface="Wingdings" panose="05000000000000000000" pitchFamily="2" charset="2"/>
+              </a:rPr>
+              <a:t> -&gt; Diagramme und </a:t>
+            </a:r>
+            <a:r>
+              <a:rPr lang="de-DE" dirty="0" err="1">
+                <a:sym typeface="Wingdings" panose="05000000000000000000" pitchFamily="2" charset="2"/>
+              </a:rPr>
+              <a:t>plots</a:t>
+            </a:r>
+            <a:endParaRPr lang="de-DE" dirty="0">
+              <a:sym typeface="Wingdings" panose="05000000000000000000" pitchFamily="2" charset="2"/>
+            </a:endParaRPr>
+          </a:p>
+          <a:p>
+            <a:r>
+              <a:rPr lang="de-DE" dirty="0">
+                <a:sym typeface="Wingdings" panose="05000000000000000000" pitchFamily="2" charset="2"/>
+              </a:rPr>
+              <a:t>Future Work &amp; </a:t>
+            </a:r>
+            <a:r>
+              <a:rPr lang="de-DE" dirty="0" err="1">
+                <a:sym typeface="Wingdings" panose="05000000000000000000" pitchFamily="2" charset="2"/>
+              </a:rPr>
+              <a:t>Conclusion</a:t>
+            </a:r>
+            <a:r>
+              <a:rPr lang="de-DE" dirty="0">
+                <a:sym typeface="Wingdings" panose="05000000000000000000" pitchFamily="2" charset="2"/>
+              </a:rPr>
+              <a:t> </a:t>
+            </a:r>
+            <a:endParaRPr lang="de-CH" dirty="0"/>
+          </a:p>
+          <a:p>
+            <a:endParaRPr lang="de-DE" dirty="0"/>
+          </a:p>
+          <a:p>
+            <a:endParaRPr lang="de-CH" dirty="0"/>
+          </a:p>
+        </p:txBody>
+      </p:sp>
+    </p:spTree>
+    <p:extLst>
+      <p:ext uri="{BB962C8B-B14F-4D97-AF65-F5344CB8AC3E}">
+        <p14:creationId xmlns:p14="http://schemas.microsoft.com/office/powerpoint/2010/main" val="1924170833"/>
       </p:ext>
     </p:extLst>
   </p:cSld>
@@ -3947,8 +6478,9 @@
             </a:r>
           </a:p>
           <a:p>
-            <a:pPr marL="0" indent="0">
-              <a:buNone/>
+            <a:pPr>
+              <a:buFontTx/>
+              <a:buChar char="-"/>
             </a:pPr>
             <a:r>
               <a:rPr lang="en-US" dirty="0">
@@ -3956,13 +6488,35 @@
                   <a:srgbClr val="FF0000"/>
                 </a:solidFill>
               </a:rPr>
-              <a:t>- OWASP MAS</a:t>
-            </a:r>
-            <a:endParaRPr lang="de-DE" dirty="0">
+              <a:t>OWASP MAS</a:t>
+            </a:r>
+          </a:p>
+          <a:p>
+            <a:pPr>
+              <a:buFontTx/>
+              <a:buChar char="-"/>
+            </a:pPr>
+            <a:endParaRPr lang="en-US" dirty="0">
               <a:solidFill>
                 <a:srgbClr val="FF0000"/>
               </a:solidFill>
             </a:endParaRPr>
+          </a:p>
+          <a:p>
+            <a:pPr>
+              <a:buFont typeface="Wingdings" panose="05000000000000000000" pitchFamily="2" charset="2"/>
+              <a:buChar char="è"/>
+            </a:pPr>
+            <a:r>
+              <a:rPr lang="de-DE" dirty="0"/>
+              <a:t>Erwartete Tiefe?</a:t>
+            </a:r>
+          </a:p>
+          <a:p>
+            <a:pPr marL="0" indent="0">
+              <a:buNone/>
+            </a:pPr>
+            <a:endParaRPr lang="de-DE" dirty="0"/>
           </a:p>
           <a:p>
             <a:pPr marL="0" indent="0">
@@ -4254,6 +6808,262 @@
     <p:extLst>
       <p:ext uri="{BB962C8B-B14F-4D97-AF65-F5344CB8AC3E}">
         <p14:creationId xmlns:p14="http://schemas.microsoft.com/office/powerpoint/2010/main" val="2781995804"/>
+      </p:ext>
+    </p:extLst>
+  </p:cSld>
+  <p:clrMapOvr>
+    <a:masterClrMapping/>
+  </p:clrMapOvr>
+</p:sld>
+</file>
+
+<file path=ppt/slides/slide8.xml><?xml version="1.0" encoding="utf-8"?>
+<p:sld xmlns:a="http://schemas.openxmlformats.org/drawingml/2006/main" xmlns:r="http://schemas.openxmlformats.org/officeDocument/2006/relationships" xmlns:p="http://schemas.openxmlformats.org/presentationml/2006/main">
+  <p:cSld>
+    <p:spTree>
+      <p:nvGrpSpPr>
+        <p:cNvPr id="1" name="">
+          <a:extLst>
+            <a:ext uri="{FF2B5EF4-FFF2-40B4-BE49-F238E27FC236}">
+              <a16:creationId xmlns:a16="http://schemas.microsoft.com/office/drawing/2014/main" id="{D5550E67-46F9-155A-8FC1-58F6DA038DEE}"/>
+            </a:ext>
+          </a:extLst>
+        </p:cNvPr>
+        <p:cNvGrpSpPr/>
+        <p:nvPr/>
+      </p:nvGrpSpPr>
+      <p:grpSpPr>
+        <a:xfrm>
+          <a:off x="0" y="0"/>
+          <a:ext cx="0" cy="0"/>
+          <a:chOff x="0" y="0"/>
+          <a:chExt cx="0" cy="0"/>
+        </a:xfrm>
+      </p:grpSpPr>
+      <p:sp>
+        <p:nvSpPr>
+          <p:cNvPr id="2" name="Titel 1">
+            <a:extLst>
+              <a:ext uri="{FF2B5EF4-FFF2-40B4-BE49-F238E27FC236}">
+                <a16:creationId xmlns:a16="http://schemas.microsoft.com/office/drawing/2014/main" id="{BC81AF75-36E7-8EF6-F6A1-C4C9CDD21E52}"/>
+              </a:ext>
+            </a:extLst>
+          </p:cNvPr>
+          <p:cNvSpPr>
+            <a:spLocks noGrp="1"/>
+          </p:cNvSpPr>
+          <p:nvPr>
+            <p:ph type="title"/>
+          </p:nvPr>
+        </p:nvSpPr>
+        <p:spPr/>
+        <p:txBody>
+          <a:bodyPr/>
+          <a:lstStyle/>
+          <a:p>
+            <a:r>
+              <a:rPr lang="de-DE" dirty="0"/>
+              <a:t>Schriftlicher Teil - Fragen</a:t>
+            </a:r>
+            <a:endParaRPr lang="de-CH" dirty="0"/>
+          </a:p>
+        </p:txBody>
+      </p:sp>
+      <p:sp>
+        <p:nvSpPr>
+          <p:cNvPr id="3" name="Inhaltsplatzhalter 2">
+            <a:extLst>
+              <a:ext uri="{FF2B5EF4-FFF2-40B4-BE49-F238E27FC236}">
+                <a16:creationId xmlns:a16="http://schemas.microsoft.com/office/drawing/2014/main" id="{CAF2C838-41C3-86EE-2643-D86876D03A0E}"/>
+              </a:ext>
+            </a:extLst>
+          </p:cNvPr>
+          <p:cNvSpPr>
+            <a:spLocks noGrp="1"/>
+          </p:cNvSpPr>
+          <p:nvPr>
+            <p:ph idx="1"/>
+          </p:nvPr>
+        </p:nvSpPr>
+        <p:spPr/>
+        <p:txBody>
+          <a:bodyPr/>
+          <a:lstStyle/>
+          <a:p>
+            <a:r>
+              <a:rPr lang="de-DE" dirty="0"/>
+              <a:t>Unterkapitel pro </a:t>
+            </a:r>
+            <a:r>
+              <a:rPr lang="de-DE" dirty="0" err="1"/>
+              <a:t>Vulnerability</a:t>
+            </a:r>
+            <a:endParaRPr lang="de-CH" dirty="0"/>
+          </a:p>
+        </p:txBody>
+      </p:sp>
+      <p:pic>
+        <p:nvPicPr>
+          <p:cNvPr id="7" name="Grafik 6">
+            <a:extLst>
+              <a:ext uri="{FF2B5EF4-FFF2-40B4-BE49-F238E27FC236}">
+                <a16:creationId xmlns:a16="http://schemas.microsoft.com/office/drawing/2014/main" id="{CD5EB4C2-F298-1A42-E3C4-A4420CBB70AF}"/>
+              </a:ext>
+            </a:extLst>
+          </p:cNvPr>
+          <p:cNvPicPr>
+            <a:picLocks noChangeAspect="1"/>
+          </p:cNvPicPr>
+          <p:nvPr/>
+        </p:nvPicPr>
+        <p:blipFill>
+          <a:blip r:embed="rId2"/>
+          <a:stretch>
+            <a:fillRect/>
+          </a:stretch>
+        </p:blipFill>
+        <p:spPr>
+          <a:xfrm>
+            <a:off x="0" y="3172545"/>
+            <a:ext cx="12192000" cy="1657497"/>
+          </a:xfrm>
+          <a:prstGeom prst="rect">
+            <a:avLst/>
+          </a:prstGeom>
+        </p:spPr>
+      </p:pic>
+    </p:spTree>
+    <p:extLst>
+      <p:ext uri="{BB962C8B-B14F-4D97-AF65-F5344CB8AC3E}">
+        <p14:creationId xmlns:p14="http://schemas.microsoft.com/office/powerpoint/2010/main" val="3752113458"/>
+      </p:ext>
+    </p:extLst>
+  </p:cSld>
+  <p:clrMapOvr>
+    <a:masterClrMapping/>
+  </p:clrMapOvr>
+</p:sld>
+</file>
+
+<file path=ppt/slides/slide9.xml><?xml version="1.0" encoding="utf-8"?>
+<p:sld xmlns:a="http://schemas.openxmlformats.org/drawingml/2006/main" xmlns:r="http://schemas.openxmlformats.org/officeDocument/2006/relationships" xmlns:p="http://schemas.openxmlformats.org/presentationml/2006/main">
+  <p:cSld>
+    <p:spTree>
+      <p:nvGrpSpPr>
+        <p:cNvPr id="1" name="">
+          <a:extLst>
+            <a:ext uri="{FF2B5EF4-FFF2-40B4-BE49-F238E27FC236}">
+              <a16:creationId xmlns:a16="http://schemas.microsoft.com/office/drawing/2014/main" id="{BF8DBD23-CC5E-6CBA-2719-6A84E37ECBA6}"/>
+            </a:ext>
+          </a:extLst>
+        </p:cNvPr>
+        <p:cNvGrpSpPr/>
+        <p:nvPr/>
+      </p:nvGrpSpPr>
+      <p:grpSpPr>
+        <a:xfrm>
+          <a:off x="0" y="0"/>
+          <a:ext cx="0" cy="0"/>
+          <a:chOff x="0" y="0"/>
+          <a:chExt cx="0" cy="0"/>
+        </a:xfrm>
+      </p:grpSpPr>
+      <p:sp>
+        <p:nvSpPr>
+          <p:cNvPr id="2" name="Titel 1">
+            <a:extLst>
+              <a:ext uri="{FF2B5EF4-FFF2-40B4-BE49-F238E27FC236}">
+                <a16:creationId xmlns:a16="http://schemas.microsoft.com/office/drawing/2014/main" id="{EF57577E-AE97-9DDE-1F24-46974372B44A}"/>
+              </a:ext>
+            </a:extLst>
+          </p:cNvPr>
+          <p:cNvSpPr>
+            <a:spLocks noGrp="1"/>
+          </p:cNvSpPr>
+          <p:nvPr>
+            <p:ph type="title"/>
+          </p:nvPr>
+        </p:nvSpPr>
+        <p:spPr/>
+        <p:txBody>
+          <a:bodyPr/>
+          <a:lstStyle/>
+          <a:p>
+            <a:r>
+              <a:rPr lang="de-DE" dirty="0"/>
+              <a:t>Schriftlicher Teil - Fragen</a:t>
+            </a:r>
+            <a:endParaRPr lang="de-CH" dirty="0"/>
+          </a:p>
+        </p:txBody>
+      </p:sp>
+      <p:sp>
+        <p:nvSpPr>
+          <p:cNvPr id="3" name="Inhaltsplatzhalter 2">
+            <a:extLst>
+              <a:ext uri="{FF2B5EF4-FFF2-40B4-BE49-F238E27FC236}">
+                <a16:creationId xmlns:a16="http://schemas.microsoft.com/office/drawing/2014/main" id="{A7704FC1-96E9-2C10-6A4C-D988C591D6C0}"/>
+              </a:ext>
+            </a:extLst>
+          </p:cNvPr>
+          <p:cNvSpPr>
+            <a:spLocks noGrp="1"/>
+          </p:cNvSpPr>
+          <p:nvPr>
+            <p:ph idx="1"/>
+          </p:nvPr>
+        </p:nvSpPr>
+        <p:spPr/>
+        <p:txBody>
+          <a:bodyPr/>
+          <a:lstStyle/>
+          <a:p>
+            <a:r>
+              <a:rPr lang="de-DE" dirty="0"/>
+              <a:t>Unterkapitel pro </a:t>
+            </a:r>
+            <a:r>
+              <a:rPr lang="de-DE" dirty="0" err="1"/>
+              <a:t>Vulnerability</a:t>
+            </a:r>
+            <a:endParaRPr lang="de-CH" dirty="0"/>
+          </a:p>
+        </p:txBody>
+      </p:sp>
+      <p:pic>
+        <p:nvPicPr>
+          <p:cNvPr id="5" name="Grafik 4">
+            <a:extLst>
+              <a:ext uri="{FF2B5EF4-FFF2-40B4-BE49-F238E27FC236}">
+                <a16:creationId xmlns:a16="http://schemas.microsoft.com/office/drawing/2014/main" id="{E73B4D36-9425-884C-48D6-4FAC8508F431}"/>
+              </a:ext>
+            </a:extLst>
+          </p:cNvPr>
+          <p:cNvPicPr>
+            <a:picLocks noChangeAspect="1"/>
+          </p:cNvPicPr>
+          <p:nvPr/>
+        </p:nvPicPr>
+        <p:blipFill>
+          <a:blip r:embed="rId2"/>
+          <a:stretch>
+            <a:fillRect/>
+          </a:stretch>
+        </p:blipFill>
+        <p:spPr>
+          <a:xfrm>
+            <a:off x="6368142" y="1470437"/>
+            <a:ext cx="5519783" cy="5267819"/>
+          </a:xfrm>
+          <a:prstGeom prst="rect">
+            <a:avLst/>
+          </a:prstGeom>
+        </p:spPr>
+      </p:pic>
+    </p:spTree>
+    <p:extLst>
+      <p:ext uri="{BB962C8B-B14F-4D97-AF65-F5344CB8AC3E}">
+        <p14:creationId xmlns:p14="http://schemas.microsoft.com/office/powerpoint/2010/main" val="1196867875"/>
       </p:ext>
     </p:extLst>
   </p:cSld>
@@ -4576,4 +7386,319 @@
     </a:ext>
   </a:extLst>
 </a:theme>
+</file>
+
+<file path=ppt/theme/theme2.xml><?xml version="1.0" encoding="utf-8"?>
+<a:theme xmlns:a="http://schemas.openxmlformats.org/drawingml/2006/main" name="Office">
+  <a:themeElements>
+    <a:clrScheme name="Office">
+      <a:dk1>
+        <a:sysClr val="windowText" lastClr="000000"/>
+      </a:dk1>
+      <a:lt1>
+        <a:sysClr val="window" lastClr="FFFFFF"/>
+      </a:lt1>
+      <a:dk2>
+        <a:srgbClr val="0E2841"/>
+      </a:dk2>
+      <a:lt2>
+        <a:srgbClr val="E8E8E8"/>
+      </a:lt2>
+      <a:accent1>
+        <a:srgbClr val="156082"/>
+      </a:accent1>
+      <a:accent2>
+        <a:srgbClr val="E97132"/>
+      </a:accent2>
+      <a:accent3>
+        <a:srgbClr val="196B24"/>
+      </a:accent3>
+      <a:accent4>
+        <a:srgbClr val="0F9ED5"/>
+      </a:accent4>
+      <a:accent5>
+        <a:srgbClr val="A02B93"/>
+      </a:accent5>
+      <a:accent6>
+        <a:srgbClr val="4EA72E"/>
+      </a:accent6>
+      <a:hlink>
+        <a:srgbClr val="467886"/>
+      </a:hlink>
+      <a:folHlink>
+        <a:srgbClr val="96607D"/>
+      </a:folHlink>
+    </a:clrScheme>
+    <a:fontScheme name="Office">
+      <a:majorFont>
+        <a:latin typeface="Aptos Display" panose="02110004020202020204"/>
+        <a:ea typeface=""/>
+        <a:cs typeface=""/>
+        <a:font script="Jpan" typeface="游ゴシック Light"/>
+        <a:font script="Hang" typeface="맑은 고딕"/>
+        <a:font script="Hans" typeface="等线 Light"/>
+        <a:font script="Hant" typeface="新細明體"/>
+        <a:font script="Arab" typeface="Times New Roman"/>
+        <a:font script="Hebr" typeface="Times New Roman"/>
+        <a:font script="Thai" typeface="Angsana New"/>
+        <a:font script="Ethi" typeface="Nyala"/>
+        <a:font script="Beng" typeface="Vrinda"/>
+        <a:font script="Gujr" typeface="Shruti"/>
+        <a:font script="Khmr" typeface="MoolBoran"/>
+        <a:font script="Knda" typeface="Tunga"/>
+        <a:font script="Guru" typeface="Raavi"/>
+        <a:font script="Cans" typeface="Euphemia"/>
+        <a:font script="Cher" typeface="Plantagenet Cherokee"/>
+        <a:font script="Yiii" typeface="Microsoft Yi Baiti"/>
+        <a:font script="Tibt" typeface="Microsoft Himalaya"/>
+        <a:font script="Thaa" typeface="MV Boli"/>
+        <a:font script="Deva" typeface="Mangal"/>
+        <a:font script="Telu" typeface="Gautami"/>
+        <a:font script="Taml" typeface="Latha"/>
+        <a:font script="Syrc" typeface="Estrangelo Edessa"/>
+        <a:font script="Orya" typeface="Kalinga"/>
+        <a:font script="Mlym" typeface="Kartika"/>
+        <a:font script="Laoo" typeface="DokChampa"/>
+        <a:font script="Sinh" typeface="Iskoola Pota"/>
+        <a:font script="Mong" typeface="Mongolian Baiti"/>
+        <a:font script="Viet" typeface="Times New Roman"/>
+        <a:font script="Uigh" typeface="Microsoft Uighur"/>
+        <a:font script="Geor" typeface="Sylfaen"/>
+        <a:font script="Armn" typeface="Arial"/>
+        <a:font script="Bugi" typeface="Leelawadee UI"/>
+        <a:font script="Bopo" typeface="Microsoft JhengHei"/>
+        <a:font script="Java" typeface="Javanese Text"/>
+        <a:font script="Lisu" typeface="Segoe UI"/>
+        <a:font script="Mymr" typeface="Myanmar Text"/>
+        <a:font script="Nkoo" typeface="Ebrima"/>
+        <a:font script="Olck" typeface="Nirmala UI"/>
+        <a:font script="Osma" typeface="Ebrima"/>
+        <a:font script="Phag" typeface="Phagspa"/>
+        <a:font script="Syrn" typeface="Estrangelo Edessa"/>
+        <a:font script="Syrj" typeface="Estrangelo Edessa"/>
+        <a:font script="Syre" typeface="Estrangelo Edessa"/>
+        <a:font script="Sora" typeface="Nirmala UI"/>
+        <a:font script="Tale" typeface="Microsoft Tai Le"/>
+        <a:font script="Talu" typeface="Microsoft New Tai Lue"/>
+        <a:font script="Tfng" typeface="Ebrima"/>
+      </a:majorFont>
+      <a:minorFont>
+        <a:latin typeface="Aptos" panose="02110004020202020204"/>
+        <a:ea typeface=""/>
+        <a:cs typeface=""/>
+        <a:font script="Jpan" typeface="游ゴシック"/>
+        <a:font script="Hang" typeface="맑은 고딕"/>
+        <a:font script="Hans" typeface="等线"/>
+        <a:font script="Hant" typeface="新細明體"/>
+        <a:font script="Arab" typeface="Arial"/>
+        <a:font script="Hebr" typeface="Arial"/>
+        <a:font script="Thai" typeface="Cordia New"/>
+        <a:font script="Ethi" typeface="Nyala"/>
+        <a:font script="Beng" typeface="Vrinda"/>
+        <a:font script="Gujr" typeface="Shruti"/>
+        <a:font script="Khmr" typeface="DaunPenh"/>
+        <a:font script="Knda" typeface="Tunga"/>
+        <a:font script="Guru" typeface="Raavi"/>
+        <a:font script="Cans" typeface="Euphemia"/>
+        <a:font script="Cher" typeface="Plantagenet Cherokee"/>
+        <a:font script="Yiii" typeface="Microsoft Yi Baiti"/>
+        <a:font script="Tibt" typeface="Microsoft Himalaya"/>
+        <a:font script="Thaa" typeface="MV Boli"/>
+        <a:font script="Deva" typeface="Mangal"/>
+        <a:font script="Telu" typeface="Gautami"/>
+        <a:font script="Taml" typeface="Latha"/>
+        <a:font script="Syrc" typeface="Estrangelo Edessa"/>
+        <a:font script="Orya" typeface="Kalinga"/>
+        <a:font script="Mlym" typeface="Kartika"/>
+        <a:font script="Laoo" typeface="DokChampa"/>
+        <a:font script="Sinh" typeface="Iskoola Pota"/>
+        <a:font script="Mong" typeface="Mongolian Baiti"/>
+        <a:font script="Viet" typeface="Arial"/>
+        <a:font script="Uigh" typeface="Microsoft Uighur"/>
+        <a:font script="Geor" typeface="Sylfaen"/>
+        <a:font script="Armn" typeface="Arial"/>
+        <a:font script="Bugi" typeface="Leelawadee UI"/>
+        <a:font script="Bopo" typeface="Microsoft JhengHei"/>
+        <a:font script="Java" typeface="Javanese Text"/>
+        <a:font script="Lisu" typeface="Segoe UI"/>
+        <a:font script="Mymr" typeface="Myanmar Text"/>
+        <a:font script="Nkoo" typeface="Ebrima"/>
+        <a:font script="Olck" typeface="Nirmala UI"/>
+        <a:font script="Osma" typeface="Ebrima"/>
+        <a:font script="Phag" typeface="Phagspa"/>
+        <a:font script="Syrn" typeface="Estrangelo Edessa"/>
+        <a:font script="Syrj" typeface="Estrangelo Edessa"/>
+        <a:font script="Syre" typeface="Estrangelo Edessa"/>
+        <a:font script="Sora" typeface="Nirmala UI"/>
+        <a:font script="Tale" typeface="Microsoft Tai Le"/>
+        <a:font script="Talu" typeface="Microsoft New Tai Lue"/>
+        <a:font script="Tfng" typeface="Ebrima"/>
+      </a:minorFont>
+    </a:fontScheme>
+    <a:fmtScheme name="Office">
+      <a:fillStyleLst>
+        <a:solidFill>
+          <a:schemeClr val="phClr"/>
+        </a:solidFill>
+        <a:gradFill rotWithShape="1">
+          <a:gsLst>
+            <a:gs pos="0">
+              <a:schemeClr val="phClr">
+                <a:lumMod val="110000"/>
+                <a:satMod val="105000"/>
+                <a:tint val="67000"/>
+              </a:schemeClr>
+            </a:gs>
+            <a:gs pos="50000">
+              <a:schemeClr val="phClr">
+                <a:lumMod val="105000"/>
+                <a:satMod val="103000"/>
+                <a:tint val="73000"/>
+              </a:schemeClr>
+            </a:gs>
+            <a:gs pos="100000">
+              <a:schemeClr val="phClr">
+                <a:lumMod val="105000"/>
+                <a:satMod val="109000"/>
+                <a:tint val="81000"/>
+              </a:schemeClr>
+            </a:gs>
+          </a:gsLst>
+          <a:lin ang="5400000" scaled="0"/>
+        </a:gradFill>
+        <a:gradFill rotWithShape="1">
+          <a:gsLst>
+            <a:gs pos="0">
+              <a:schemeClr val="phClr">
+                <a:satMod val="103000"/>
+                <a:lumMod val="102000"/>
+                <a:tint val="94000"/>
+              </a:schemeClr>
+            </a:gs>
+            <a:gs pos="50000">
+              <a:schemeClr val="phClr">
+                <a:satMod val="110000"/>
+                <a:lumMod val="100000"/>
+                <a:shade val="100000"/>
+              </a:schemeClr>
+            </a:gs>
+            <a:gs pos="100000">
+              <a:schemeClr val="phClr">
+                <a:lumMod val="99000"/>
+                <a:satMod val="120000"/>
+                <a:shade val="78000"/>
+              </a:schemeClr>
+            </a:gs>
+          </a:gsLst>
+          <a:lin ang="5400000" scaled="0"/>
+        </a:gradFill>
+      </a:fillStyleLst>
+      <a:lnStyleLst>
+        <a:ln w="12700" cap="flat" cmpd="sng" algn="ctr">
+          <a:solidFill>
+            <a:schemeClr val="phClr"/>
+          </a:solidFill>
+          <a:prstDash val="solid"/>
+          <a:miter lim="800000"/>
+        </a:ln>
+        <a:ln w="19050" cap="flat" cmpd="sng" algn="ctr">
+          <a:solidFill>
+            <a:schemeClr val="phClr"/>
+          </a:solidFill>
+          <a:prstDash val="solid"/>
+          <a:miter lim="800000"/>
+        </a:ln>
+        <a:ln w="25400" cap="flat" cmpd="sng" algn="ctr">
+          <a:solidFill>
+            <a:schemeClr val="phClr"/>
+          </a:solidFill>
+          <a:prstDash val="solid"/>
+          <a:miter lim="800000"/>
+        </a:ln>
+      </a:lnStyleLst>
+      <a:effectStyleLst>
+        <a:effectStyle>
+          <a:effectLst/>
+        </a:effectStyle>
+        <a:effectStyle>
+          <a:effectLst/>
+        </a:effectStyle>
+        <a:effectStyle>
+          <a:effectLst>
+            <a:outerShdw blurRad="57150" dist="19050" dir="5400000" algn="ctr" rotWithShape="0">
+              <a:srgbClr val="000000">
+                <a:alpha val="63000"/>
+              </a:srgbClr>
+            </a:outerShdw>
+          </a:effectLst>
+        </a:effectStyle>
+      </a:effectStyleLst>
+      <a:bgFillStyleLst>
+        <a:solidFill>
+          <a:schemeClr val="phClr"/>
+        </a:solidFill>
+        <a:solidFill>
+          <a:schemeClr val="phClr">
+            <a:tint val="95000"/>
+            <a:satMod val="170000"/>
+          </a:schemeClr>
+        </a:solidFill>
+        <a:gradFill rotWithShape="1">
+          <a:gsLst>
+            <a:gs pos="0">
+              <a:schemeClr val="phClr">
+                <a:tint val="93000"/>
+                <a:satMod val="150000"/>
+                <a:shade val="98000"/>
+                <a:lumMod val="102000"/>
+              </a:schemeClr>
+            </a:gs>
+            <a:gs pos="50000">
+              <a:schemeClr val="phClr">
+                <a:tint val="98000"/>
+                <a:satMod val="130000"/>
+                <a:shade val="90000"/>
+                <a:lumMod val="103000"/>
+              </a:schemeClr>
+            </a:gs>
+            <a:gs pos="100000">
+              <a:schemeClr val="phClr">
+                <a:shade val="63000"/>
+                <a:satMod val="120000"/>
+              </a:schemeClr>
+            </a:gs>
+          </a:gsLst>
+          <a:lin ang="5400000" scaled="0"/>
+        </a:gradFill>
+      </a:bgFillStyleLst>
+    </a:fmtScheme>
+  </a:themeElements>
+  <a:objectDefaults>
+    <a:lnDef>
+      <a:spPr/>
+      <a:bodyPr/>
+      <a:lstStyle/>
+      <a:style>
+        <a:lnRef idx="2">
+          <a:schemeClr val="accent1"/>
+        </a:lnRef>
+        <a:fillRef idx="0">
+          <a:schemeClr val="accent1"/>
+        </a:fillRef>
+        <a:effectRef idx="1">
+          <a:schemeClr val="accent1"/>
+        </a:effectRef>
+        <a:fontRef idx="minor">
+          <a:schemeClr val="tx1"/>
+        </a:fontRef>
+      </a:style>
+    </a:lnDef>
+  </a:objectDefaults>
+  <a:extraClrSchemeLst/>
+  <a:extLst>
+    <a:ext uri="{05A4C25C-085E-4340-85A3-A5531E510DB2}">
+      <thm15:themeFamily xmlns:thm15="http://schemas.microsoft.com/office/thememl/2012/main" name="Office Theme" id="{2E142A2C-CD16-42D6-873A-C26D2A0506FA}" vid="{1BDDFF52-6CD6-40A5-AB3C-68EB2F1E4D0A}"/>
+    </a:ext>
+  </a:extLst>
+</a:theme>
 </file>
</xml_diff>